<commit_message>
Retours soutenance (diapos 6-10) : rôle admin DBA, coûts détaillés, ELT, tâches DAG
- Entrepôt : 3e rôle eckert_admin (DBA gatekeeper, DDL) — SQL init + live +
  livrable C4-2-1 + preuve schéma (3 rôles)
- Coûts C4-1-2 : coût humain de l'alternant chiffré, ressources Azure/SaaS
  détaillées et sourcées (Snowflake usage vs Fabric capacité)
- Conducteur : diapo 6 (coûts détaillés), 7 (3 rôles), 8 (ELT vs ETL),
  9 (rôle de chaque tâche), 10 (partage Postgres/Spark + INSEE partiel)
- Inclut la mise en forme du .pptx en cours par l'auteur

Co-Authored-By: Claude Opus 4.8 <noreply@anthropic.com>
</commit_message>
<xml_diff>
--- a/soutenance/support_eckert.pptx
+++ b/soutenance/support_eckert.pptx
@@ -4,29 +4,32 @@
   <p:sldMasterIdLst>
     <p:sldMasterId id="2147483648" r:id="rId1"/>
   </p:sldMasterIdLst>
+  <p:notesMasterIdLst>
+    <p:notesMasterId r:id="rId22"/>
+  </p:notesMasterIdLst>
   <p:sldIdLst>
-    <p:sldId id="256" r:id="rId7"/>
-    <p:sldId id="257" r:id="rId9"/>
-    <p:sldId id="258" r:id="rId10"/>
-    <p:sldId id="259" r:id="rId11"/>
-    <p:sldId id="260" r:id="rId12"/>
-    <p:sldId id="261" r:id="rId13"/>
-    <p:sldId id="262" r:id="rId14"/>
-    <p:sldId id="263" r:id="rId15"/>
-    <p:sldId id="264" r:id="rId16"/>
-    <p:sldId id="265" r:id="rId17"/>
-    <p:sldId id="266" r:id="rId18"/>
-    <p:sldId id="267" r:id="rId19"/>
-    <p:sldId id="268" r:id="rId20"/>
-    <p:sldId id="269" r:id="rId21"/>
-    <p:sldId id="270" r:id="rId22"/>
-    <p:sldId id="271" r:id="rId23"/>
-    <p:sldId id="272" r:id="rId24"/>
-    <p:sldId id="273" r:id="rId25"/>
-    <p:sldId id="274" r:id="rId26"/>
-    <p:sldId id="275" r:id="rId27"/>
+    <p:sldId id="256" r:id="rId2"/>
+    <p:sldId id="257" r:id="rId3"/>
+    <p:sldId id="258" r:id="rId4"/>
+    <p:sldId id="259" r:id="rId5"/>
+    <p:sldId id="260" r:id="rId6"/>
+    <p:sldId id="261" r:id="rId7"/>
+    <p:sldId id="262" r:id="rId8"/>
+    <p:sldId id="263" r:id="rId9"/>
+    <p:sldId id="264" r:id="rId10"/>
+    <p:sldId id="265" r:id="rId11"/>
+    <p:sldId id="266" r:id="rId12"/>
+    <p:sldId id="267" r:id="rId13"/>
+    <p:sldId id="268" r:id="rId14"/>
+    <p:sldId id="269" r:id="rId15"/>
+    <p:sldId id="270" r:id="rId16"/>
+    <p:sldId id="271" r:id="rId17"/>
+    <p:sldId id="272" r:id="rId18"/>
+    <p:sldId id="273" r:id="rId19"/>
+    <p:sldId id="274" r:id="rId20"/>
+    <p:sldId id="275" r:id="rId21"/>
   </p:sldIdLst>
-  <p:sldSz cx="12192000" cy="6858000" type="screen4x3"/>
+  <p:sldSz cx="12192000" cy="6858000"/>
   <p:notesSz cx="6858000" cy="9144000"/>
   <p:defaultTextStyle>
     <a:defPPr>
@@ -123,11 +126,27 @@
       </a:defRPr>
     </a:lvl9pPr>
   </p:defaultTextStyle>
+  <p:extLst>
+    <p:ext uri="{EFAFB233-063F-42B5-8137-9DF3F51BA10A}">
+      <p15:sldGuideLst xmlns:p15="http://schemas.microsoft.com/office/powerpoint/2012/main">
+        <p15:guide id="1" orient="horz" pos="2160">
+          <p15:clr>
+            <a:srgbClr val="A4A3A4"/>
+          </p15:clr>
+        </p15:guide>
+        <p15:guide id="2" pos="2880">
+          <p15:clr>
+            <a:srgbClr val="A4A3A4"/>
+          </p15:clr>
+        </p15:guide>
+      </p15:sldGuideLst>
+    </p:ext>
+  </p:extLst>
 </p:presentation>
 </file>
 
 <file path=ppt/notesMasters/notesMaster1.xml><?xml version="1.0" encoding="utf-8"?>
-<p:notesMaster xmlns:a="http://schemas.openxmlformats.org/drawingml/2006/main" xmlns:p="http://schemas.openxmlformats.org/presentationml/2006/main" xmlns:r="http://schemas.openxmlformats.org/officeDocument/2006/relationships">
+<p:notesMaster xmlns:a="http://schemas.openxmlformats.org/drawingml/2006/main" xmlns:r="http://schemas.openxmlformats.org/officeDocument/2006/relationships" xmlns:p="http://schemas.openxmlformats.org/presentationml/2006/main">
   <p:cSld>
     <p:bg>
       <p:bgRef idx="1001">
@@ -148,241 +167,16 @@
           <a:chExt cx="0" cy="0"/>
         </a:xfrm>
       </p:grpSpPr>
-      <p:sp>
-        <p:nvSpPr>
-          <p:cNvPr id="2" name="Header Placeholder 1"/>
-          <p:cNvSpPr>
-            <a:spLocks noGrp="1"/>
-          </p:cNvSpPr>
-          <p:nvPr>
-            <p:ph type="hdr" sz="quarter"/>
-          </p:nvPr>
-        </p:nvSpPr>
-        <p:spPr>
-          <a:xfrm>
-            <a:off x="0" y="0"/>
-            <a:ext cx="2971800" cy="457200"/>
-          </a:xfrm>
-          <a:prstGeom prst="rect">
-            <a:avLst/>
-          </a:prstGeom>
-        </p:spPr>
-        <p:txBody>
-          <a:bodyPr vert="horz" lIns="91440" tIns="45720" rIns="91440" bIns="45720" rtlCol="0"/>
-          <a:lstStyle>
-            <a:lvl1pPr algn="l">
-              <a:defRPr sz="1200"/>
-            </a:lvl1pPr>
-          </a:lstStyle>
-          <a:p>
-            <a:endParaRPr lang="en-US"/>
-          </a:p>
-        </p:txBody>
-      </p:sp>
-      <p:sp>
-        <p:nvSpPr>
-          <p:cNvPr id="3" name="Date Placeholder 2"/>
-          <p:cNvSpPr>
-            <a:spLocks noGrp="1"/>
-          </p:cNvSpPr>
-          <p:nvPr>
-            <p:ph type="dt" idx="1"/>
-          </p:nvPr>
-        </p:nvSpPr>
-        <p:spPr>
-          <a:xfrm>
-            <a:off x="3884613" y="0"/>
-            <a:ext cx="2971800" cy="457200"/>
-          </a:xfrm>
-          <a:prstGeom prst="rect">
-            <a:avLst/>
-          </a:prstGeom>
-        </p:spPr>
-        <p:txBody>
-          <a:bodyPr vert="horz" lIns="91440" tIns="45720" rIns="91440" bIns="45720" rtlCol="0"/>
-          <a:lstStyle>
-            <a:lvl1pPr algn="r">
-              <a:defRPr sz="1200"/>
-            </a:lvl1pPr>
-          </a:lstStyle>
-          <a:p>
-            <a:fld id="{0F89C1C7-3DCD-1040-A9CF-14679D8B5DDD}" type="datetimeFigureOut">
-              <a:rPr lang="en-US" smtClean="0"/>
-              <a:t>10/17/16</a:t>
-            </a:fld>
-            <a:endParaRPr lang="en-US"/>
-          </a:p>
-        </p:txBody>
-      </p:sp>
-      <p:sp>
-        <p:nvSpPr>
-          <p:cNvPr id="4" name="Slide Image Placeholder 3"/>
-          <p:cNvSpPr>
-            <a:spLocks noGrp="1" noRot="1" noChangeAspect="1"/>
-          </p:cNvSpPr>
-          <p:nvPr>
-            <p:ph type="sldImg" idx="2"/>
-          </p:nvPr>
-        </p:nvSpPr>
-        <p:spPr>
-          <a:xfrm>
-            <a:off x="1143000" y="685800"/>
-            <a:ext cx="4572000" cy="3429000"/>
-          </a:xfrm>
-          <a:prstGeom prst="rect">
-            <a:avLst/>
-          </a:prstGeom>
-          <a:noFill/>
-          <a:ln w="12700">
-            <a:solidFill>
-              <a:prstClr val="black"/>
-            </a:solidFill>
-          </a:ln>
-        </p:spPr>
-        <p:txBody>
-          <a:bodyPr vert="horz" lIns="91440" tIns="45720" rIns="91440" bIns="45720" rtlCol="0" anchor="ctr"/>
-          <a:lstStyle/>
-          <a:p>
-            <a:endParaRPr lang="en-US"/>
-          </a:p>
-        </p:txBody>
-      </p:sp>
-      <p:sp>
-        <p:nvSpPr>
-          <p:cNvPr id="5" name="Notes Placeholder 4"/>
-          <p:cNvSpPr>
-            <a:spLocks noGrp="1"/>
-          </p:cNvSpPr>
-          <p:nvPr>
-            <p:ph type="body" sz="quarter" idx="3"/>
-          </p:nvPr>
-        </p:nvSpPr>
-        <p:spPr>
-          <a:xfrm>
-            <a:off x="685800" y="4343400"/>
-            <a:ext cx="5486400" cy="4114800"/>
-          </a:xfrm>
-          <a:prstGeom prst="rect">
-            <a:avLst/>
-          </a:prstGeom>
-        </p:spPr>
-        <p:txBody>
-          <a:bodyPr vert="horz" lIns="91440" tIns="45720" rIns="91440" bIns="45720" rtlCol="0"/>
-          <a:lstStyle/>
-          <a:p>
-            <a:pPr lvl="0"/>
-            <a:r>
-              <a:rPr lang="en-US" smtClean="0"/>
-              <a:t>Click to edit Master text styles</a:t>
-            </a:r>
-          </a:p>
-          <a:p>
-            <a:pPr lvl="1"/>
-            <a:r>
-              <a:rPr lang="en-US" smtClean="0"/>
-              <a:t>Second level</a:t>
-            </a:r>
-          </a:p>
-          <a:p>
-            <a:pPr lvl="2"/>
-            <a:r>
-              <a:rPr lang="en-US" smtClean="0"/>
-              <a:t>Third level</a:t>
-            </a:r>
-          </a:p>
-          <a:p>
-            <a:pPr lvl="3"/>
-            <a:r>
-              <a:rPr lang="en-US" smtClean="0"/>
-              <a:t>Fourth level</a:t>
-            </a:r>
-          </a:p>
-          <a:p>
-            <a:pPr lvl="4"/>
-            <a:r>
-              <a:rPr lang="en-US" smtClean="0"/>
-              <a:t>Fifth level</a:t>
-            </a:r>
-            <a:endParaRPr lang="en-US"/>
-          </a:p>
-        </p:txBody>
-      </p:sp>
-      <p:sp>
-        <p:nvSpPr>
-          <p:cNvPr id="6" name="Footer Placeholder 5"/>
-          <p:cNvSpPr>
-            <a:spLocks noGrp="1"/>
-          </p:cNvSpPr>
-          <p:nvPr>
-            <p:ph type="ftr" sz="quarter" idx="4"/>
-          </p:nvPr>
-        </p:nvSpPr>
-        <p:spPr>
-          <a:xfrm>
-            <a:off x="0" y="8685213"/>
-            <a:ext cx="2971800" cy="457200"/>
-          </a:xfrm>
-          <a:prstGeom prst="rect">
-            <a:avLst/>
-          </a:prstGeom>
-        </p:spPr>
-        <p:txBody>
-          <a:bodyPr vert="horz" lIns="91440" tIns="45720" rIns="91440" bIns="45720" rtlCol="0" anchor="b"/>
-          <a:lstStyle>
-            <a:lvl1pPr algn="l">
-              <a:defRPr sz="1200"/>
-            </a:lvl1pPr>
-          </a:lstStyle>
-          <a:p>
-            <a:endParaRPr lang="en-US"/>
-          </a:p>
-        </p:txBody>
-      </p:sp>
-      <p:sp>
-        <p:nvSpPr>
-          <p:cNvPr id="7" name="Slide Number Placeholder 6"/>
-          <p:cNvSpPr>
-            <a:spLocks noGrp="1"/>
-          </p:cNvSpPr>
-          <p:nvPr>
-            <p:ph type="sldNum" sz="quarter" idx="5"/>
-          </p:nvPr>
-        </p:nvSpPr>
-        <p:spPr>
-          <a:xfrm>
-            <a:off x="3884613" y="8685213"/>
-            <a:ext cx="2971800" cy="457200"/>
-          </a:xfrm>
-          <a:prstGeom prst="rect">
-            <a:avLst/>
-          </a:prstGeom>
-        </p:spPr>
-        <p:txBody>
-          <a:bodyPr vert="horz" lIns="91440" tIns="45720" rIns="91440" bIns="45720" rtlCol="0" anchor="b"/>
-          <a:lstStyle>
-            <a:lvl1pPr algn="r">
-              <a:defRPr sz="1200"/>
-            </a:lvl1pPr>
-          </a:lstStyle>
-          <a:p>
-            <a:fld id="{BB5E49A5-4136-284D-997B-48E1D791AD67}" type="slidenum">
-              <a:rPr lang="en-US" smtClean="0"/>
-              <a:t>‹#›</a:t>
-            </a:fld>
-            <a:endParaRPr lang="en-US"/>
-          </a:p>
-        </p:txBody>
-      </p:sp>
     </p:spTree>
     <p:extLst>
       <p:ext uri="{BB962C8B-B14F-4D97-AF65-F5344CB8AC3E}">
-        <p14:creationId xmlns:p14="http://schemas.microsoft.com/office/powerpoint/2010/main" val="2623252185"/>
+        <p14:creationId xmlns:p14="http://schemas.microsoft.com/office/powerpoint/2010/main" val="2424729202"/>
       </p:ext>
     </p:extLst>
   </p:cSld>
   <p:clrMap bg1="lt1" tx1="dk1" bg2="lt2" tx2="dk2" accent1="accent1" accent2="accent2" accent3="accent3" accent4="accent4" accent5="accent5" accent6="accent6" hlink="hlink" folHlink="folHlink"/>
   <p:notesStyle>
-    <a:lvl1pPr marL="0" algn="l" defTabSz="457200" rtl="0" eaLnBrk="1" latinLnBrk="0" hangingPunct="1">
+    <a:lvl1pPr marL="0" algn="l" defTabSz="914400" rtl="0" eaLnBrk="1" latinLnBrk="0" hangingPunct="1">
       <a:defRPr sz="1200" kern="1200">
         <a:solidFill>
           <a:schemeClr val="tx1"/>
@@ -392,7 +186,7 @@
         <a:cs typeface="+mn-cs"/>
       </a:defRPr>
     </a:lvl1pPr>
-    <a:lvl2pPr marL="457200" algn="l" defTabSz="457200" rtl="0" eaLnBrk="1" latinLnBrk="0" hangingPunct="1">
+    <a:lvl2pPr marL="457200" algn="l" defTabSz="914400" rtl="0" eaLnBrk="1" latinLnBrk="0" hangingPunct="1">
       <a:defRPr sz="1200" kern="1200">
         <a:solidFill>
           <a:schemeClr val="tx1"/>
@@ -402,7 +196,7 @@
         <a:cs typeface="+mn-cs"/>
       </a:defRPr>
     </a:lvl2pPr>
-    <a:lvl3pPr marL="914400" algn="l" defTabSz="457200" rtl="0" eaLnBrk="1" latinLnBrk="0" hangingPunct="1">
+    <a:lvl3pPr marL="914400" algn="l" defTabSz="914400" rtl="0" eaLnBrk="1" latinLnBrk="0" hangingPunct="1">
       <a:defRPr sz="1200" kern="1200">
         <a:solidFill>
           <a:schemeClr val="tx1"/>
@@ -412,7 +206,7 @@
         <a:cs typeface="+mn-cs"/>
       </a:defRPr>
     </a:lvl3pPr>
-    <a:lvl4pPr marL="1371600" algn="l" defTabSz="457200" rtl="0" eaLnBrk="1" latinLnBrk="0" hangingPunct="1">
+    <a:lvl4pPr marL="1371600" algn="l" defTabSz="914400" rtl="0" eaLnBrk="1" latinLnBrk="0" hangingPunct="1">
       <a:defRPr sz="1200" kern="1200">
         <a:solidFill>
           <a:schemeClr val="tx1"/>
@@ -422,7 +216,7 @@
         <a:cs typeface="+mn-cs"/>
       </a:defRPr>
     </a:lvl4pPr>
-    <a:lvl5pPr marL="1828800" algn="l" defTabSz="457200" rtl="0" eaLnBrk="1" latinLnBrk="0" hangingPunct="1">
+    <a:lvl5pPr marL="1828800" algn="l" defTabSz="914400" rtl="0" eaLnBrk="1" latinLnBrk="0" hangingPunct="1">
       <a:defRPr sz="1200" kern="1200">
         <a:solidFill>
           <a:schemeClr val="tx1"/>
@@ -432,7 +226,7 @@
         <a:cs typeface="+mn-cs"/>
       </a:defRPr>
     </a:lvl5pPr>
-    <a:lvl6pPr marL="2286000" algn="l" defTabSz="457200" rtl="0" eaLnBrk="1" latinLnBrk="0" hangingPunct="1">
+    <a:lvl6pPr marL="2286000" algn="l" defTabSz="914400" rtl="0" eaLnBrk="1" latinLnBrk="0" hangingPunct="1">
       <a:defRPr sz="1200" kern="1200">
         <a:solidFill>
           <a:schemeClr val="tx1"/>
@@ -442,7 +236,7 @@
         <a:cs typeface="+mn-cs"/>
       </a:defRPr>
     </a:lvl6pPr>
-    <a:lvl7pPr marL="2743200" algn="l" defTabSz="457200" rtl="0" eaLnBrk="1" latinLnBrk="0" hangingPunct="1">
+    <a:lvl7pPr marL="2743200" algn="l" defTabSz="914400" rtl="0" eaLnBrk="1" latinLnBrk="0" hangingPunct="1">
       <a:defRPr sz="1200" kern="1200">
         <a:solidFill>
           <a:schemeClr val="tx1"/>
@@ -452,7 +246,7 @@
         <a:cs typeface="+mn-cs"/>
       </a:defRPr>
     </a:lvl7pPr>
-    <a:lvl8pPr marL="3200400" algn="l" defTabSz="457200" rtl="0" eaLnBrk="1" latinLnBrk="0" hangingPunct="1">
+    <a:lvl8pPr marL="3200400" algn="l" defTabSz="914400" rtl="0" eaLnBrk="1" latinLnBrk="0" hangingPunct="1">
       <a:defRPr sz="1200" kern="1200">
         <a:solidFill>
           <a:schemeClr val="tx1"/>
@@ -462,7 +256,7 @@
         <a:cs typeface="+mn-cs"/>
       </a:defRPr>
     </a:lvl8pPr>
-    <a:lvl9pPr marL="3657600" algn="l" defTabSz="457200" rtl="0" eaLnBrk="1" latinLnBrk="0" hangingPunct="1">
+    <a:lvl9pPr marL="3657600" algn="l" defTabSz="914400" rtl="0" eaLnBrk="1" latinLnBrk="0" hangingPunct="1">
       <a:defRPr sz="1200" kern="1200">
         <a:solidFill>
           <a:schemeClr val="tx1"/>
@@ -477,7 +271,7 @@
 </file>
 
 <file path=ppt/notesSlides/notesSlide1.xml><?xml version="1.0" encoding="utf-8"?>
-<p:notes xmlns:a="http://schemas.openxmlformats.org/drawingml/2006/main" xmlns:p="http://schemas.openxmlformats.org/presentationml/2006/main" xmlns:r="http://schemas.openxmlformats.org/officeDocument/2006/relationships">
+<p:notes xmlns:a="http://schemas.openxmlformats.org/drawingml/2006/main" xmlns:r="http://schemas.openxmlformats.org/officeDocument/2006/relationships" xmlns:p="http://schemas.openxmlformats.org/presentationml/2006/main">
   <p:cSld>
     <p:spTree>
       <p:nvGrpSpPr>
@@ -497,7 +291,7 @@
         <p:nvSpPr>
           <p:cNvPr id="2" name="Slide Image Placeholder 1"/>
           <p:cNvSpPr>
-            <a:spLocks noGrp="1"/>
+            <a:spLocks noGrp="1" noRot="1" noChangeAspect="1"/>
           </p:cNvSpPr>
           <p:nvPr>
             <p:ph type="sldImg" idx="2"/>
@@ -512,7 +306,7 @@
             <a:spLocks noGrp="1"/>
           </p:cNvSpPr>
           <p:nvPr>
-            <p:ph type="body" idx="3" sz="quarter"/>
+            <p:ph type="body" sz="quarter" idx="3"/>
           </p:nvPr>
         </p:nvSpPr>
         <p:spPr/>
@@ -520,9 +314,7 @@
           <a:bodyPr/>
           <a:lstStyle/>
           <a:p>
-            <a:r>
-              <a:t>Bonjour. En 30 minutes, je vous présente une plateforme data que j'ai conçue et opérée pour répondre à l'obligation loi Eckert, puis je réponds à vos questions.</a:t>
-            </a:r>
+            <a:endParaRPr dirty="0"/>
           </a:p>
         </p:txBody>
       </p:sp>
@@ -533,7 +325,7 @@
             <a:spLocks noGrp="1"/>
           </p:cNvSpPr>
           <p:nvPr>
-            <p:ph type="sldNum" idx="5" sz="quarter"/>
+            <p:ph type="sldNum" sz="quarter" idx="5"/>
           </p:nvPr>
         </p:nvSpPr>
         <p:spPr/>
@@ -547,7 +339,7 @@
 </file>
 
 <file path=ppt/notesSlides/notesSlide10.xml><?xml version="1.0" encoding="utf-8"?>
-<p:notes xmlns:a="http://schemas.openxmlformats.org/drawingml/2006/main" xmlns:p="http://schemas.openxmlformats.org/presentationml/2006/main" xmlns:r="http://schemas.openxmlformats.org/officeDocument/2006/relationships">
+<p:notes xmlns:a="http://schemas.openxmlformats.org/drawingml/2006/main" xmlns:r="http://schemas.openxmlformats.org/officeDocument/2006/relationships" xmlns:p="http://schemas.openxmlformats.org/presentationml/2006/main">
   <p:cSld>
     <p:spTree>
       <p:nvGrpSpPr>
@@ -567,7 +359,7 @@
         <p:nvSpPr>
           <p:cNvPr id="2" name="Slide Image Placeholder 1"/>
           <p:cNvSpPr>
-            <a:spLocks noGrp="1"/>
+            <a:spLocks noGrp="1" noRot="1" noChangeAspect="1"/>
           </p:cNvSpPr>
           <p:nvPr>
             <p:ph type="sldImg" idx="2"/>
@@ -582,7 +374,7 @@
             <a:spLocks noGrp="1"/>
           </p:cNvSpPr>
           <p:nvPr>
-            <p:ph type="body" idx="3" sz="quarter"/>
+            <p:ph type="body" sz="quarter" idx="3"/>
           </p:nvPr>
         </p:nvSpPr>
         <p:spPr/>
@@ -590,9 +382,7 @@
           <a:bodyPr/>
           <a:lstStyle/>
           <a:p>
-            <a:r>
-              <a:t>Le rapprochement tourne sur un cluster Spark et gradue la confiance en trois niveaux, faute d'identifiant national. Résultat : 4 162 contrats potentiellement en déshérence, dont 88 millions d'euros en niveau certain. Sur le seul volume mensuel, un Postgres indexé suffirait — je l'assume ; Spark se justifie par la volumétrie cumulée et la trajectoire de croissance.</a:t>
-            </a:r>
+            <a:endParaRPr dirty="0"/>
           </a:p>
         </p:txBody>
       </p:sp>
@@ -603,7 +393,7 @@
             <a:spLocks noGrp="1"/>
           </p:cNvSpPr>
           <p:nvPr>
-            <p:ph type="sldNum" idx="5" sz="quarter"/>
+            <p:ph type="sldNum" sz="quarter" idx="5"/>
           </p:nvPr>
         </p:nvSpPr>
         <p:spPr/>
@@ -617,7 +407,7 @@
 </file>
 
 <file path=ppt/notesSlides/notesSlide11.xml><?xml version="1.0" encoding="utf-8"?>
-<p:notes xmlns:a="http://schemas.openxmlformats.org/drawingml/2006/main" xmlns:p="http://schemas.openxmlformats.org/presentationml/2006/main" xmlns:r="http://schemas.openxmlformats.org/officeDocument/2006/relationships">
+<p:notes xmlns:a="http://schemas.openxmlformats.org/drawingml/2006/main" xmlns:r="http://schemas.openxmlformats.org/officeDocument/2006/relationships" xmlns:p="http://schemas.openxmlformats.org/presentationml/2006/main">
   <p:cSld>
     <p:spTree>
       <p:nvGrpSpPr>
@@ -637,7 +427,7 @@
         <p:nvSpPr>
           <p:cNvPr id="2" name="Slide Image Placeholder 1"/>
           <p:cNvSpPr>
-            <a:spLocks noGrp="1"/>
+            <a:spLocks noGrp="1" noRot="1" noChangeAspect="1"/>
           </p:cNvSpPr>
           <p:nvPr>
             <p:ph type="sldImg" idx="2"/>
@@ -652,7 +442,7 @@
             <a:spLocks noGrp="1"/>
           </p:cNvSpPr>
           <p:nvPr>
-            <p:ph type="body" idx="3" sz="quarter"/>
+            <p:ph type="body" sz="quarter" idx="3"/>
           </p:nvPr>
         </p:nvSpPr>
         <p:spPr/>
@@ -660,9 +450,7 @@
           <a:bodyPr/>
           <a:lstStyle/>
           <a:p>
-            <a:r>
-              <a:t>La CI/CD, construite de zéro, enchaîne cinq contrôles à chaque push : qualité, tests, scan de sécurité, validation des DAG, et déploiement. Le déploiement est réel : l'image est publiée sur le registre GitHub, puis re-téléchargée et testée. Détail assumé : mon premier run était rouge — la preuve que les garde-fous mordent.</a:t>
-            </a:r>
+            <a:endParaRPr dirty="0"/>
           </a:p>
         </p:txBody>
       </p:sp>
@@ -673,7 +461,7 @@
             <a:spLocks noGrp="1"/>
           </p:cNvSpPr>
           <p:nvPr>
-            <p:ph type="sldNum" idx="5" sz="quarter"/>
+            <p:ph type="sldNum" sz="quarter" idx="5"/>
           </p:nvPr>
         </p:nvSpPr>
         <p:spPr/>
@@ -687,7 +475,7 @@
 </file>
 
 <file path=ppt/notesSlides/notesSlide12.xml><?xml version="1.0" encoding="utf-8"?>
-<p:notes xmlns:a="http://schemas.openxmlformats.org/drawingml/2006/main" xmlns:p="http://schemas.openxmlformats.org/presentationml/2006/main" xmlns:r="http://schemas.openxmlformats.org/officeDocument/2006/relationships">
+<p:notes xmlns:a="http://schemas.openxmlformats.org/drawingml/2006/main" xmlns:r="http://schemas.openxmlformats.org/officeDocument/2006/relationships" xmlns:p="http://schemas.openxmlformats.org/presentationml/2006/main">
   <p:cSld>
     <p:spTree>
       <p:nvGrpSpPr>
@@ -707,7 +495,7 @@
         <p:nvSpPr>
           <p:cNvPr id="2" name="Slide Image Placeholder 1"/>
           <p:cNvSpPr>
-            <a:spLocks noGrp="1"/>
+            <a:spLocks noGrp="1" noRot="1" noChangeAspect="1"/>
           </p:cNvSpPr>
           <p:nvPr>
             <p:ph type="sldImg" idx="2"/>
@@ -722,7 +510,7 @@
             <a:spLocks noGrp="1"/>
           </p:cNvSpPr>
           <p:nvPr>
-            <p:ph type="body" idx="3" sz="quarter"/>
+            <p:ph type="body" sz="quarter" idx="3"/>
           </p:nvPr>
         </p:nvSpPr>
         <p:spPr/>
@@ -730,9 +518,7 @@
           <a:bodyPr/>
           <a:lstStyle/>
           <a:p>
-            <a:r>
-              <a:t>La supervision surveille le statut, les SLA et surtout le taux de rejet. Chaque étape est journalisée. Sur échec, une alerte part vraiment : j'ai capturé la notification reçue par le destinataire, avec le lien vers le journal. Un dépassement de délai escalade par courriel.</a:t>
-            </a:r>
+            <a:endParaRPr dirty="0"/>
           </a:p>
         </p:txBody>
       </p:sp>
@@ -743,7 +529,7 @@
             <a:spLocks noGrp="1"/>
           </p:cNvSpPr>
           <p:nvPr>
-            <p:ph type="sldNum" idx="5" sz="quarter"/>
+            <p:ph type="sldNum" sz="quarter" idx="5"/>
           </p:nvPr>
         </p:nvSpPr>
         <p:spPr/>
@@ -757,7 +543,7 @@
 </file>
 
 <file path=ppt/notesSlides/notesSlide13.xml><?xml version="1.0" encoding="utf-8"?>
-<p:notes xmlns:a="http://schemas.openxmlformats.org/drawingml/2006/main" xmlns:p="http://schemas.openxmlformats.org/presentationml/2006/main" xmlns:r="http://schemas.openxmlformats.org/officeDocument/2006/relationships">
+<p:notes xmlns:a="http://schemas.openxmlformats.org/drawingml/2006/main" xmlns:r="http://schemas.openxmlformats.org/officeDocument/2006/relationships" xmlns:p="http://schemas.openxmlformats.org/presentationml/2006/main">
   <p:cSld>
     <p:spTree>
       <p:nvGrpSpPr>
@@ -777,7 +563,7 @@
         <p:nvSpPr>
           <p:cNvPr id="2" name="Slide Image Placeholder 1"/>
           <p:cNvSpPr>
-            <a:spLocks noGrp="1"/>
+            <a:spLocks noGrp="1" noRot="1" noChangeAspect="1"/>
           </p:cNvSpPr>
           <p:nvPr>
             <p:ph type="sldImg" idx="2"/>
@@ -792,7 +578,7 @@
             <a:spLocks noGrp="1"/>
           </p:cNvSpPr>
           <p:nvPr>
-            <p:ph type="body" idx="3" sz="quarter"/>
+            <p:ph type="body" sz="quarter" idx="3"/>
           </p:nvPr>
         </p:nvSpPr>
         <p:spPr/>
@@ -800,9 +586,7 @@
           <a:bodyPr/>
           <a:lstStyle/>
           <a:p>
-            <a:r>
-              <a:t>Une feuille de route calendaire cadre la maintenance : rotation des secrets au trimestre, certificats au semestre. Et une documentation avec runbook permet à un successeur de reprendre sans moi — d'ailleurs c'est cette procédure qui a servi à monter la plateforme.</a:t>
-            </a:r>
+            <a:endParaRPr dirty="0"/>
           </a:p>
         </p:txBody>
       </p:sp>
@@ -813,7 +597,7 @@
             <a:spLocks noGrp="1"/>
           </p:cNvSpPr>
           <p:nvPr>
-            <p:ph type="sldNum" idx="5" sz="quarter"/>
+            <p:ph type="sldNum" sz="quarter" idx="5"/>
           </p:nvPr>
         </p:nvSpPr>
         <p:spPr/>
@@ -827,7 +611,7 @@
 </file>
 
 <file path=ppt/notesSlides/notesSlide14.xml><?xml version="1.0" encoding="utf-8"?>
-<p:notes xmlns:a="http://schemas.openxmlformats.org/drawingml/2006/main" xmlns:p="http://schemas.openxmlformats.org/presentationml/2006/main" xmlns:r="http://schemas.openxmlformats.org/officeDocument/2006/relationships">
+<p:notes xmlns:a="http://schemas.openxmlformats.org/drawingml/2006/main" xmlns:r="http://schemas.openxmlformats.org/officeDocument/2006/relationships" xmlns:p="http://schemas.openxmlformats.org/presentationml/2006/main">
   <p:cSld>
     <p:spTree>
       <p:nvGrpSpPr>
@@ -847,7 +631,7 @@
         <p:nvSpPr>
           <p:cNvPr id="2" name="Slide Image Placeholder 1"/>
           <p:cNvSpPr>
-            <a:spLocks noGrp="1"/>
+            <a:spLocks noGrp="1" noRot="1" noChangeAspect="1"/>
           </p:cNvSpPr>
           <p:nvPr>
             <p:ph type="sldImg" idx="2"/>
@@ -862,7 +646,7 @@
             <a:spLocks noGrp="1"/>
           </p:cNvSpPr>
           <p:nvPr>
-            <p:ph type="body" idx="3" sz="quarter"/>
+            <p:ph type="body" sz="quarter" idx="3"/>
           </p:nvPr>
         </p:nvSpPr>
         <p:spPr/>
@@ -870,9 +654,7 @@
           <a:bodyPr/>
           <a:lstStyle/>
           <a:p>
-            <a:r>
-              <a:t>La recette est automatisée : dix-neuf tests fonctionnels, structurels et de sécurité — les droits, les secrets, les dépendances. Elle est rejouée à chaque push. Ce n'est pas un instantané, c'est un filet permanent. Je peux la lancer en direct : elle passe en moins d'une seconde.</a:t>
-            </a:r>
+            <a:endParaRPr dirty="0"/>
           </a:p>
         </p:txBody>
       </p:sp>
@@ -883,7 +665,7 @@
             <a:spLocks noGrp="1"/>
           </p:cNvSpPr>
           <p:nvPr>
-            <p:ph type="sldNum" idx="5" sz="quarter"/>
+            <p:ph type="sldNum" sz="quarter" idx="5"/>
           </p:nvPr>
         </p:nvSpPr>
         <p:spPr/>
@@ -897,7 +679,7 @@
 </file>
 
 <file path=ppt/notesSlides/notesSlide15.xml><?xml version="1.0" encoding="utf-8"?>
-<p:notes xmlns:a="http://schemas.openxmlformats.org/drawingml/2006/main" xmlns:p="http://schemas.openxmlformats.org/presentationml/2006/main" xmlns:r="http://schemas.openxmlformats.org/officeDocument/2006/relationships">
+<p:notes xmlns:a="http://schemas.openxmlformats.org/drawingml/2006/main" xmlns:r="http://schemas.openxmlformats.org/officeDocument/2006/relationships" xmlns:p="http://schemas.openxmlformats.org/presentationml/2006/main">
   <p:cSld>
     <p:spTree>
       <p:nvGrpSpPr>
@@ -917,7 +699,7 @@
         <p:nvSpPr>
           <p:cNvPr id="2" name="Slide Image Placeholder 1"/>
           <p:cNvSpPr>
-            <a:spLocks noGrp="1"/>
+            <a:spLocks noGrp="1" noRot="1" noChangeAspect="1"/>
           </p:cNvSpPr>
           <p:nvPr>
             <p:ph type="sldImg" idx="2"/>
@@ -932,7 +714,7 @@
             <a:spLocks noGrp="1"/>
           </p:cNvSpPr>
           <p:nvPr>
-            <p:ph type="body" idx="3" sz="quarter"/>
+            <p:ph type="body" sz="quarter" idx="3"/>
           </p:nvPr>
         </p:nvSpPr>
         <p:spPr/>
@@ -941,8 +723,10 @@
           <a:lstStyle/>
           <a:p>
             <a:r>
-              <a:t>Voici l'incident, vécu en production. Le contrôle d'entrée validait le fichier sur ses métadonnées déclarées : taille et empreinte annoncées. Après deux mois nominaux, le producteur a cessé de les publier. Résultat : rejet systématique, traitement en erreur chaque jour — alors que les fichiers étaient parfaitement exploitables. La cause n'est pas triviale : le contrat de données change sans préavis, côté producteur.</a:t>
-            </a:r>
+              <a:rPr lang="fr-FR" dirty="0"/>
+              <a:t>=</a:t>
+            </a:r>
+            <a:endParaRPr dirty="0"/>
           </a:p>
         </p:txBody>
       </p:sp>
@@ -953,7 +737,7 @@
             <a:spLocks noGrp="1"/>
           </p:cNvSpPr>
           <p:nvPr>
-            <p:ph type="sldNum" idx="5" sz="quarter"/>
+            <p:ph type="sldNum" sz="quarter" idx="5"/>
           </p:nvPr>
         </p:nvSpPr>
         <p:spPr/>
@@ -967,7 +751,7 @@
 </file>
 
 <file path=ppt/notesSlides/notesSlide16.xml><?xml version="1.0" encoding="utf-8"?>
-<p:notes xmlns:a="http://schemas.openxmlformats.org/drawingml/2006/main" xmlns:p="http://schemas.openxmlformats.org/presentationml/2006/main" xmlns:r="http://schemas.openxmlformats.org/officeDocument/2006/relationships">
+<p:notes xmlns:a="http://schemas.openxmlformats.org/drawingml/2006/main" xmlns:r="http://schemas.openxmlformats.org/officeDocument/2006/relationships" xmlns:p="http://schemas.openxmlformats.org/presentationml/2006/main">
   <p:cSld>
     <p:spTree>
       <p:nvGrpSpPr>
@@ -987,7 +771,7 @@
         <p:nvSpPr>
           <p:cNvPr id="2" name="Slide Image Placeholder 1"/>
           <p:cNvSpPr>
-            <a:spLocks noGrp="1"/>
+            <a:spLocks noGrp="1" noRot="1" noChangeAspect="1"/>
           </p:cNvSpPr>
           <p:nvPr>
             <p:ph type="sldImg" idx="2"/>
@@ -1002,7 +786,7 @@
             <a:spLocks noGrp="1"/>
           </p:cNvSpPr>
           <p:nvPr>
-            <p:ph type="body" idx="3" sz="quarter"/>
+            <p:ph type="body" sz="quarter" idx="3"/>
           </p:nvPr>
         </p:nvSpPr>
         <p:spPr/>
@@ -1010,9 +794,7 @@
           <a:bodyPr/>
           <a:lstStyle/>
           <a:p>
-            <a:r>
-              <a:t>Le correctif inverse la logique : les métadonnées ne font qu'alerter, la vérité c'est le contenu — structure, volumétrie, taux de rejet. Un fichier sain sans métadonnées passe désormais ; un fichier corrompu reste bloqué. Un test de non-régression verrouille le cas. Je peux rejouer l'avant/après en direct, en moins d'une seconde. La leçon : une source externe n'est jamais un contrat.</a:t>
-            </a:r>
+            <a:endParaRPr dirty="0"/>
           </a:p>
         </p:txBody>
       </p:sp>
@@ -1023,7 +805,7 @@
             <a:spLocks noGrp="1"/>
           </p:cNvSpPr>
           <p:nvPr>
-            <p:ph type="sldNum" idx="5" sz="quarter"/>
+            <p:ph type="sldNum" sz="quarter" idx="5"/>
           </p:nvPr>
         </p:nvSpPr>
         <p:spPr/>
@@ -1037,7 +819,7 @@
 </file>
 
 <file path=ppt/notesSlides/notesSlide17.xml><?xml version="1.0" encoding="utf-8"?>
-<p:notes xmlns:a="http://schemas.openxmlformats.org/drawingml/2006/main" xmlns:p="http://schemas.openxmlformats.org/presentationml/2006/main" xmlns:r="http://schemas.openxmlformats.org/officeDocument/2006/relationships">
+<p:notes xmlns:a="http://schemas.openxmlformats.org/drawingml/2006/main" xmlns:r="http://schemas.openxmlformats.org/officeDocument/2006/relationships" xmlns:p="http://schemas.openxmlformats.org/presentationml/2006/main">
   <p:cSld>
     <p:spTree>
       <p:nvGrpSpPr>
@@ -1057,7 +839,7 @@
         <p:nvSpPr>
           <p:cNvPr id="2" name="Slide Image Placeholder 1"/>
           <p:cNvSpPr>
-            <a:spLocks noGrp="1"/>
+            <a:spLocks noGrp="1" noRot="1" noChangeAspect="1"/>
           </p:cNvSpPr>
           <p:nvPr>
             <p:ph type="sldImg" idx="2"/>
@@ -1072,7 +854,7 @@
             <a:spLocks noGrp="1"/>
           </p:cNvSpPr>
           <p:nvPr>
-            <p:ph type="body" idx="3" sz="quarter"/>
+            <p:ph type="body" sz="quarter" idx="3"/>
           </p:nvPr>
         </p:nvSpPr>
         <p:spPr/>
@@ -1080,9 +862,7 @@
           <a:bodyPr/>
           <a:lstStyle/>
           <a:p>
-            <a:r>
-              <a:t>En bilan : la chaîne complète tourne et est prouvée, la sécurité est testée, la CI est verte, l'incident est rejoué. J'assume mes limites : une seule instance Postgres, le job Spark lancé manuellement, pas de supervision d'infrastructure. Si je continuais, j'outillerais le déclenchement Spark par Airflow et une supervision infra. Merci — je suis prêt pour vos questions.</a:t>
-            </a:r>
+            <a:endParaRPr dirty="0"/>
           </a:p>
         </p:txBody>
       </p:sp>
@@ -1093,7 +873,7 @@
             <a:spLocks noGrp="1"/>
           </p:cNvSpPr>
           <p:nvPr>
-            <p:ph type="sldNum" idx="5" sz="quarter"/>
+            <p:ph type="sldNum" sz="quarter" idx="5"/>
           </p:nvPr>
         </p:nvSpPr>
         <p:spPr/>
@@ -1107,7 +887,7 @@
 </file>
 
 <file path=ppt/notesSlides/notesSlide18.xml><?xml version="1.0" encoding="utf-8"?>
-<p:notes xmlns:a="http://schemas.openxmlformats.org/drawingml/2006/main" xmlns:p="http://schemas.openxmlformats.org/presentationml/2006/main" xmlns:r="http://schemas.openxmlformats.org/officeDocument/2006/relationships">
+<p:notes xmlns:a="http://schemas.openxmlformats.org/drawingml/2006/main" xmlns:r="http://schemas.openxmlformats.org/officeDocument/2006/relationships" xmlns:p="http://schemas.openxmlformats.org/presentationml/2006/main">
   <p:cSld>
     <p:spTree>
       <p:nvGrpSpPr>
@@ -1127,7 +907,7 @@
         <p:nvSpPr>
           <p:cNvPr id="2" name="Slide Image Placeholder 1"/>
           <p:cNvSpPr>
-            <a:spLocks noGrp="1"/>
+            <a:spLocks noGrp="1" noRot="1" noChangeAspect="1"/>
           </p:cNvSpPr>
           <p:nvPr>
             <p:ph type="sldImg" idx="2"/>
@@ -1142,7 +922,7 @@
             <a:spLocks noGrp="1"/>
           </p:cNvSpPr>
           <p:nvPr>
-            <p:ph type="body" idx="3" sz="quarter"/>
+            <p:ph type="body" sz="quarter" idx="3"/>
           </p:nvPr>
         </p:nvSpPr>
         <p:spPr/>
@@ -1150,9 +930,7 @@
           <a:bodyPr/>
           <a:lstStyle/>
           <a:p>
-            <a:r>
-              <a:t>Annexe ouverte si le jury creuse l'entrepôt.</a:t>
-            </a:r>
+            <a:endParaRPr dirty="0"/>
           </a:p>
         </p:txBody>
       </p:sp>
@@ -1163,7 +941,7 @@
             <a:spLocks noGrp="1"/>
           </p:cNvSpPr>
           <p:nvPr>
-            <p:ph type="sldNum" idx="5" sz="quarter"/>
+            <p:ph type="sldNum" sz="quarter" idx="5"/>
           </p:nvPr>
         </p:nvSpPr>
         <p:spPr/>
@@ -1177,7 +955,7 @@
 </file>
 
 <file path=ppt/notesSlides/notesSlide19.xml><?xml version="1.0" encoding="utf-8"?>
-<p:notes xmlns:a="http://schemas.openxmlformats.org/drawingml/2006/main" xmlns:p="http://schemas.openxmlformats.org/presentationml/2006/main" xmlns:r="http://schemas.openxmlformats.org/officeDocument/2006/relationships">
+<p:notes xmlns:a="http://schemas.openxmlformats.org/drawingml/2006/main" xmlns:r="http://schemas.openxmlformats.org/officeDocument/2006/relationships" xmlns:p="http://schemas.openxmlformats.org/presentationml/2006/main">
   <p:cSld>
     <p:spTree>
       <p:nvGrpSpPr>
@@ -1197,7 +975,7 @@
         <p:nvSpPr>
           <p:cNvPr id="2" name="Slide Image Placeholder 1"/>
           <p:cNvSpPr>
-            <a:spLocks noGrp="1"/>
+            <a:spLocks noGrp="1" noRot="1" noChangeAspect="1"/>
           </p:cNvSpPr>
           <p:nvPr>
             <p:ph type="sldImg" idx="2"/>
@@ -1212,7 +990,7 @@
             <a:spLocks noGrp="1"/>
           </p:cNvSpPr>
           <p:nvPr>
-            <p:ph type="body" idx="3" sz="quarter"/>
+            <p:ph type="body" sz="quarter" idx="3"/>
           </p:nvPr>
         </p:nvSpPr>
         <p:spPr/>
@@ -1220,9 +998,7 @@
           <a:bodyPr/>
           <a:lstStyle/>
           <a:p>
-            <a:r>
-              <a:t>Annexe ouverte sur une question de coût ou de lock-in.</a:t>
-            </a:r>
+            <a:endParaRPr dirty="0"/>
           </a:p>
         </p:txBody>
       </p:sp>
@@ -1233,7 +1009,7 @@
             <a:spLocks noGrp="1"/>
           </p:cNvSpPr>
           <p:nvPr>
-            <p:ph type="sldNum" idx="5" sz="quarter"/>
+            <p:ph type="sldNum" sz="quarter" idx="5"/>
           </p:nvPr>
         </p:nvSpPr>
         <p:spPr/>
@@ -1247,7 +1023,7 @@
 </file>
 
 <file path=ppt/notesSlides/notesSlide2.xml><?xml version="1.0" encoding="utf-8"?>
-<p:notes xmlns:a="http://schemas.openxmlformats.org/drawingml/2006/main" xmlns:p="http://schemas.openxmlformats.org/presentationml/2006/main" xmlns:r="http://schemas.openxmlformats.org/officeDocument/2006/relationships">
+<p:notes xmlns:a="http://schemas.openxmlformats.org/drawingml/2006/main" xmlns:r="http://schemas.openxmlformats.org/officeDocument/2006/relationships" xmlns:p="http://schemas.openxmlformats.org/presentationml/2006/main">
   <p:cSld>
     <p:spTree>
       <p:nvGrpSpPr>
@@ -1267,7 +1043,7 @@
         <p:nvSpPr>
           <p:cNvPr id="2" name="Slide Image Placeholder 1"/>
           <p:cNvSpPr>
-            <a:spLocks noGrp="1"/>
+            <a:spLocks noGrp="1" noRot="1" noChangeAspect="1"/>
           </p:cNvSpPr>
           <p:nvPr>
             <p:ph type="sldImg" idx="2"/>
@@ -1282,7 +1058,7 @@
             <a:spLocks noGrp="1"/>
           </p:cNvSpPr>
           <p:nvPr>
-            <p:ph type="body" idx="3" sz="quarter"/>
+            <p:ph type="body" sz="quarter" idx="3"/>
           </p:nvPr>
         </p:nvSpPr>
         <p:spPr/>
@@ -1290,9 +1066,7 @@
           <a:bodyPr/>
           <a:lstStyle/>
           <a:p>
-            <a:r>
-              <a:t>Une mutuelle doit repérer ses adhérents décédés pour verser les capitaux des contrats en déshérence. C'est une obligation légale — la loi Eckert — sous risque de sanction. La source de vérité, c'est le fichier des décès de l'INSEE.</a:t>
-            </a:r>
+            <a:endParaRPr dirty="0"/>
           </a:p>
         </p:txBody>
       </p:sp>
@@ -1303,7 +1077,7 @@
             <a:spLocks noGrp="1"/>
           </p:cNvSpPr>
           <p:nvPr>
-            <p:ph type="sldNum" idx="5" sz="quarter"/>
+            <p:ph type="sldNum" sz="quarter" idx="5"/>
           </p:nvPr>
         </p:nvSpPr>
         <p:spPr/>
@@ -1317,7 +1091,7 @@
 </file>
 
 <file path=ppt/notesSlides/notesSlide20.xml><?xml version="1.0" encoding="utf-8"?>
-<p:notes xmlns:a="http://schemas.openxmlformats.org/drawingml/2006/main" xmlns:p="http://schemas.openxmlformats.org/presentationml/2006/main" xmlns:r="http://schemas.openxmlformats.org/officeDocument/2006/relationships">
+<p:notes xmlns:a="http://schemas.openxmlformats.org/drawingml/2006/main" xmlns:r="http://schemas.openxmlformats.org/officeDocument/2006/relationships" xmlns:p="http://schemas.openxmlformats.org/presentationml/2006/main">
   <p:cSld>
     <p:spTree>
       <p:nvGrpSpPr>
@@ -1337,7 +1111,7 @@
         <p:nvSpPr>
           <p:cNvPr id="2" name="Slide Image Placeholder 1"/>
           <p:cNvSpPr>
-            <a:spLocks noGrp="1"/>
+            <a:spLocks noGrp="1" noRot="1" noChangeAspect="1"/>
           </p:cNvSpPr>
           <p:nvPr>
             <p:ph type="sldImg" idx="2"/>
@@ -1352,7 +1126,7 @@
             <a:spLocks noGrp="1"/>
           </p:cNvSpPr>
           <p:nvPr>
-            <p:ph type="body" idx="3" sz="quarter"/>
+            <p:ph type="body" sz="quarter" idx="3"/>
           </p:nvPr>
         </p:nvSpPr>
         <p:spPr/>
@@ -1360,9 +1134,7 @@
           <a:bodyPr/>
           <a:lstStyle/>
           <a:p>
-            <a:r>
-              <a:t>Annexe ouverte sur une question CI/CD ou déploiement.</a:t>
-            </a:r>
+            <a:endParaRPr dirty="0"/>
           </a:p>
         </p:txBody>
       </p:sp>
@@ -1373,7 +1145,7 @@
             <a:spLocks noGrp="1"/>
           </p:cNvSpPr>
           <p:nvPr>
-            <p:ph type="sldNum" idx="5" sz="quarter"/>
+            <p:ph type="sldNum" sz="quarter" idx="5"/>
           </p:nvPr>
         </p:nvSpPr>
         <p:spPr/>
@@ -1387,7 +1159,7 @@
 </file>
 
 <file path=ppt/notesSlides/notesSlide3.xml><?xml version="1.0" encoding="utf-8"?>
-<p:notes xmlns:a="http://schemas.openxmlformats.org/drawingml/2006/main" xmlns:p="http://schemas.openxmlformats.org/presentationml/2006/main" xmlns:r="http://schemas.openxmlformats.org/officeDocument/2006/relationships">
+<p:notes xmlns:a="http://schemas.openxmlformats.org/drawingml/2006/main" xmlns:r="http://schemas.openxmlformats.org/officeDocument/2006/relationships" xmlns:p="http://schemas.openxmlformats.org/presentationml/2006/main">
   <p:cSld>
     <p:spTree>
       <p:nvGrpSpPr>
@@ -1407,7 +1179,7 @@
         <p:nvSpPr>
           <p:cNvPr id="2" name="Slide Image Placeholder 1"/>
           <p:cNvSpPr>
-            <a:spLocks noGrp="1"/>
+            <a:spLocks noGrp="1" noRot="1" noChangeAspect="1"/>
           </p:cNvSpPr>
           <p:nvPr>
             <p:ph type="sldImg" idx="2"/>
@@ -1422,7 +1194,7 @@
             <a:spLocks noGrp="1"/>
           </p:cNvSpPr>
           <p:nvPr>
-            <p:ph type="body" idx="3" sz="quarter"/>
+            <p:ph type="body" sz="quarter" idx="3"/>
           </p:nvPr>
         </p:nvSpPr>
         <p:spPr/>
@@ -1430,9 +1202,7 @@
           <a:bodyPr/>
           <a:lstStyle/>
           <a:p>
-            <a:r>
-              <a:t>Point d'honnêteté important : j'ai reconstruit entièrement cette plateforme, sur un contexte réel. Ce n'est pas le SI de l'entreprise. Le fichier décès est la vraie donnée publique, mais le référentiel adhérents est synthétique, généré avec Faker : aucune donnée personnelle réelle. J'ai vécu l'ingestion Eckert en production, et l'incident que je rejouerai à la fin.</a:t>
-            </a:r>
+            <a:endParaRPr dirty="0"/>
           </a:p>
         </p:txBody>
       </p:sp>
@@ -1443,7 +1213,7 @@
             <a:spLocks noGrp="1"/>
           </p:cNvSpPr>
           <p:nvPr>
-            <p:ph type="sldNum" idx="5" sz="quarter"/>
+            <p:ph type="sldNum" sz="quarter" idx="5"/>
           </p:nvPr>
         </p:nvSpPr>
         <p:spPr/>
@@ -1457,7 +1227,7 @@
 </file>
 
 <file path=ppt/notesSlides/notesSlide4.xml><?xml version="1.0" encoding="utf-8"?>
-<p:notes xmlns:a="http://schemas.openxmlformats.org/drawingml/2006/main" xmlns:p="http://schemas.openxmlformats.org/presentationml/2006/main" xmlns:r="http://schemas.openxmlformats.org/officeDocument/2006/relationships">
+<p:notes xmlns:a="http://schemas.openxmlformats.org/drawingml/2006/main" xmlns:r="http://schemas.openxmlformats.org/officeDocument/2006/relationships" xmlns:p="http://schemas.openxmlformats.org/presentationml/2006/main">
   <p:cSld>
     <p:spTree>
       <p:nvGrpSpPr>
@@ -1477,7 +1247,7 @@
         <p:nvSpPr>
           <p:cNvPr id="2" name="Slide Image Placeholder 1"/>
           <p:cNvSpPr>
-            <a:spLocks noGrp="1"/>
+            <a:spLocks noGrp="1" noRot="1" noChangeAspect="1"/>
           </p:cNvSpPr>
           <p:nvPr>
             <p:ph type="sldImg" idx="2"/>
@@ -1492,7 +1262,7 @@
             <a:spLocks noGrp="1"/>
           </p:cNvSpPr>
           <p:nvPr>
-            <p:ph type="body" idx="3" sz="quarter"/>
+            <p:ph type="body" sz="quarter" idx="3"/>
           </p:nvPr>
         </p:nvSpPr>
         <p:spPr/>
@@ -1500,9 +1270,7 @@
           <a:bodyPr/>
           <a:lstStyle/>
           <a:p>
-            <a:r>
-              <a:t>Trois contraintes cadrent tout : coût nul, donc tout en local ; délai court, donc chaque brique démontrable en cinq minutes ; et une forte volumétrie. L'existant couvrait SQL Server et un Airflow. Mais quatre compétences n'avaient aucun matériau : le distribué, la CI/CD, l'alerting et les tests de sécurité. Ce sont mes priorités.</a:t>
-            </a:r>
+            <a:endParaRPr dirty="0"/>
           </a:p>
         </p:txBody>
       </p:sp>
@@ -1513,7 +1281,7 @@
             <a:spLocks noGrp="1"/>
           </p:cNvSpPr>
           <p:nvPr>
-            <p:ph type="sldNum" idx="5" sz="quarter"/>
+            <p:ph type="sldNum" sz="quarter" idx="5"/>
           </p:nvPr>
         </p:nvSpPr>
         <p:spPr/>
@@ -1527,7 +1295,7 @@
 </file>
 
 <file path=ppt/notesSlides/notesSlide5.xml><?xml version="1.0" encoding="utf-8"?>
-<p:notes xmlns:a="http://schemas.openxmlformats.org/drawingml/2006/main" xmlns:p="http://schemas.openxmlformats.org/presentationml/2006/main" xmlns:r="http://schemas.openxmlformats.org/officeDocument/2006/relationships">
+<p:notes xmlns:a="http://schemas.openxmlformats.org/drawingml/2006/main" xmlns:r="http://schemas.openxmlformats.org/officeDocument/2006/relationships" xmlns:p="http://schemas.openxmlformats.org/presentationml/2006/main">
   <p:cSld>
     <p:spTree>
       <p:nvGrpSpPr>
@@ -1547,7 +1315,7 @@
         <p:nvSpPr>
           <p:cNvPr id="2" name="Slide Image Placeholder 1"/>
           <p:cNvSpPr>
-            <a:spLocks noGrp="1"/>
+            <a:spLocks noGrp="1" noRot="1" noChangeAspect="1"/>
           </p:cNvSpPr>
           <p:nvPr>
             <p:ph type="sldImg" idx="2"/>
@@ -1562,7 +1330,7 @@
             <a:spLocks noGrp="1"/>
           </p:cNvSpPr>
           <p:nvPr>
-            <p:ph type="body" idx="3" sz="quarter"/>
+            <p:ph type="body" sz="quarter" idx="3"/>
           </p:nvPr>
         </p:nvSpPr>
         <p:spPr/>
@@ -1570,9 +1338,7 @@
           <a:bodyPr/>
           <a:lstStyle/>
           <a:p>
-            <a:r>
-              <a:t>J'ai retenu cinq briques open source. Toutes exposent des interfaces standard — S3, SQL, PySpark — ce qui traite le vendor lock-in par conception : je peux basculer vers le cloud sans réécriture majeure.</a:t>
-            </a:r>
+            <a:endParaRPr dirty="0"/>
           </a:p>
         </p:txBody>
       </p:sp>
@@ -1583,7 +1349,7 @@
             <a:spLocks noGrp="1"/>
           </p:cNvSpPr>
           <p:nvPr>
-            <p:ph type="sldNum" idx="5" sz="quarter"/>
+            <p:ph type="sldNum" sz="quarter" idx="5"/>
           </p:nvPr>
         </p:nvSpPr>
         <p:spPr/>
@@ -1597,7 +1363,7 @@
 </file>
 
 <file path=ppt/notesSlides/notesSlide6.xml><?xml version="1.0" encoding="utf-8"?>
-<p:notes xmlns:a="http://schemas.openxmlformats.org/drawingml/2006/main" xmlns:p="http://schemas.openxmlformats.org/presentationml/2006/main" xmlns:r="http://schemas.openxmlformats.org/officeDocument/2006/relationships">
+<p:notes xmlns:a="http://schemas.openxmlformats.org/drawingml/2006/main" xmlns:r="http://schemas.openxmlformats.org/officeDocument/2006/relationships" xmlns:p="http://schemas.openxmlformats.org/presentationml/2006/main">
   <p:cSld>
     <p:spTree>
       <p:nvGrpSpPr>
@@ -1617,7 +1383,7 @@
         <p:nvSpPr>
           <p:cNvPr id="2" name="Slide Image Placeholder 1"/>
           <p:cNvSpPr>
-            <a:spLocks noGrp="1"/>
+            <a:spLocks noGrp="1" noRot="1" noChangeAspect="1"/>
           </p:cNvSpPr>
           <p:nvPr>
             <p:ph type="sldImg" idx="2"/>
@@ -1632,7 +1398,7 @@
             <a:spLocks noGrp="1"/>
           </p:cNvSpPr>
           <p:nvPr>
-            <p:ph type="body" idx="3" sz="quarter"/>
+            <p:ph type="body" sz="quarter" idx="3"/>
           </p:nvPr>
         </p:nvSpPr>
         <p:spPr/>
@@ -1640,9 +1406,7 @@
           <a:bodyPr/>
           <a:lstStyle/>
           <a:p>
-            <a:r>
-              <a:t>Sur le coût, j'ai chiffré trois scénarios avec des hypothèses assumées. Le local coûte surtout du temps humain ; Azure, 50 à 145 € par mois ; le SaaS, 80 à 250. Dans le contexte réel, le SaaS a été écarté pour son coût récurrent et la souveraineté des données de santé. Le jury attend une méthode de chiffrage, pas un devis exact.</a:t>
-            </a:r>
+            <a:endParaRPr dirty="0"/>
           </a:p>
         </p:txBody>
       </p:sp>
@@ -1653,7 +1417,7 @@
             <a:spLocks noGrp="1"/>
           </p:cNvSpPr>
           <p:nvPr>
-            <p:ph type="sldNum" idx="5" sz="quarter"/>
+            <p:ph type="sldNum" sz="quarter" idx="5"/>
           </p:nvPr>
         </p:nvSpPr>
         <p:spPr/>
@@ -1667,7 +1431,7 @@
 </file>
 
 <file path=ppt/notesSlides/notesSlide7.xml><?xml version="1.0" encoding="utf-8"?>
-<p:notes xmlns:a="http://schemas.openxmlformats.org/drawingml/2006/main" xmlns:p="http://schemas.openxmlformats.org/presentationml/2006/main" xmlns:r="http://schemas.openxmlformats.org/officeDocument/2006/relationships">
+<p:notes xmlns:a="http://schemas.openxmlformats.org/drawingml/2006/main" xmlns:r="http://schemas.openxmlformats.org/officeDocument/2006/relationships" xmlns:p="http://schemas.openxmlformats.org/presentationml/2006/main">
   <p:cSld>
     <p:spTree>
       <p:nvGrpSpPr>
@@ -1687,7 +1451,7 @@
         <p:nvSpPr>
           <p:cNvPr id="2" name="Slide Image Placeholder 1"/>
           <p:cNvSpPr>
-            <a:spLocks noGrp="1"/>
+            <a:spLocks noGrp="1" noRot="1" noChangeAspect="1"/>
           </p:cNvSpPr>
           <p:nvPr>
             <p:ph type="sldImg" idx="2"/>
@@ -1702,7 +1466,7 @@
             <a:spLocks noGrp="1"/>
           </p:cNvSpPr>
           <p:nvPr>
-            <p:ph type="body" idx="3" sz="quarter"/>
+            <p:ph type="body" sz="quarter" idx="3"/>
           </p:nvPr>
         </p:nvSpPr>
         <p:spPr/>
@@ -1710,9 +1474,7 @@
           <a:bodyPr/>
           <a:lstStyle/>
           <a:p>
-            <a:r>
-              <a:t>L'entrepôt est en quatre couches : le brut, le nettoyé, le métier, le journal. Deux rôles appliquent le moindre privilège. Et je le prouve par des tests : le rôle lecture ne peut ni écrire, ni lire le brut. Le métier consomme une vue déjà priorisée par niveau de confiance.</a:t>
-            </a:r>
+            <a:endParaRPr dirty="0"/>
           </a:p>
         </p:txBody>
       </p:sp>
@@ -1723,7 +1485,7 @@
             <a:spLocks noGrp="1"/>
           </p:cNvSpPr>
           <p:nvPr>
-            <p:ph type="sldNum" idx="5" sz="quarter"/>
+            <p:ph type="sldNum" sz="quarter" idx="5"/>
           </p:nvPr>
         </p:nvSpPr>
         <p:spPr/>
@@ -1737,7 +1499,7 @@
 </file>
 
 <file path=ppt/notesSlides/notesSlide8.xml><?xml version="1.0" encoding="utf-8"?>
-<p:notes xmlns:a="http://schemas.openxmlformats.org/drawingml/2006/main" xmlns:p="http://schemas.openxmlformats.org/presentationml/2006/main" xmlns:r="http://schemas.openxmlformats.org/officeDocument/2006/relationships">
+<p:notes xmlns:a="http://schemas.openxmlformats.org/drawingml/2006/main" xmlns:r="http://schemas.openxmlformats.org/officeDocument/2006/relationships" xmlns:p="http://schemas.openxmlformats.org/presentationml/2006/main">
   <p:cSld>
     <p:spTree>
       <p:nvGrpSpPr>
@@ -1757,7 +1519,7 @@
         <p:nvSpPr>
           <p:cNvPr id="2" name="Slide Image Placeholder 1"/>
           <p:cNvSpPr>
-            <a:spLocks noGrp="1"/>
+            <a:spLocks noGrp="1" noRot="1" noChangeAspect="1"/>
           </p:cNvSpPr>
           <p:nvPr>
             <p:ph type="sldImg" idx="2"/>
@@ -1772,7 +1534,7 @@
             <a:spLocks noGrp="1"/>
           </p:cNvSpPr>
           <p:nvPr>
-            <p:ph type="body" idx="3" sz="quarter"/>
+            <p:ph type="body" sz="quarter" idx="3"/>
           </p:nvPr>
         </p:nvSpPr>
         <p:spPr/>
@@ -1780,9 +1542,7 @@
           <a:bodyPr/>
           <a:lstStyle/>
           <a:p>
-            <a:r>
-              <a:t>La compétence pipelines exige trois méthodes. Le fil de l'eau, en SQL, nettoie et dédoublonne au plus près de la donnée. L'orchestration Airflow enchaîne et fiabilise. Et le distribué, avec Spark, absorbe le volume du rapprochement. Les trois tournent.</a:t>
-            </a:r>
+            <a:endParaRPr dirty="0"/>
           </a:p>
         </p:txBody>
       </p:sp>
@@ -1793,7 +1553,7 @@
             <a:spLocks noGrp="1"/>
           </p:cNvSpPr>
           <p:nvPr>
-            <p:ph type="sldNum" idx="5" sz="quarter"/>
+            <p:ph type="sldNum" sz="quarter" idx="5"/>
           </p:nvPr>
         </p:nvSpPr>
         <p:spPr/>
@@ -1807,7 +1567,7 @@
 </file>
 
 <file path=ppt/notesSlides/notesSlide9.xml><?xml version="1.0" encoding="utf-8"?>
-<p:notes xmlns:a="http://schemas.openxmlformats.org/drawingml/2006/main" xmlns:p="http://schemas.openxmlformats.org/presentationml/2006/main" xmlns:r="http://schemas.openxmlformats.org/officeDocument/2006/relationships">
+<p:notes xmlns:a="http://schemas.openxmlformats.org/drawingml/2006/main" xmlns:r="http://schemas.openxmlformats.org/officeDocument/2006/relationships" xmlns:p="http://schemas.openxmlformats.org/presentationml/2006/main">
   <p:cSld>
     <p:spTree>
       <p:nvGrpSpPr>
@@ -1827,7 +1587,7 @@
         <p:nvSpPr>
           <p:cNvPr id="2" name="Slide Image Placeholder 1"/>
           <p:cNvSpPr>
-            <a:spLocks noGrp="1"/>
+            <a:spLocks noGrp="1" noRot="1" noChangeAspect="1"/>
           </p:cNvSpPr>
           <p:nvPr>
             <p:ph type="sldImg" idx="2"/>
@@ -1842,7 +1602,7 @@
             <a:spLocks noGrp="1"/>
           </p:cNvSpPr>
           <p:nvPr>
-            <p:ph type="body" idx="3" sz="quarter"/>
+            <p:ph type="body" sz="quarter" idx="3"/>
           </p:nvPr>
         </p:nvSpPr>
         <p:spPr/>
@@ -1850,9 +1610,7 @@
           <a:bodyPr/>
           <a:lstStyle/>
           <a:p>
-            <a:r>
-              <a:t>Voici le DAG réel : quatre tâches, de la récupération du catalogue à la promotion silver, avec retries, SLA et callbacks. Il tourne au vert sur le vrai fichier INSEE téléchargé depuis data.gouv.</a:t>
-            </a:r>
+            <a:endParaRPr dirty="0"/>
           </a:p>
         </p:txBody>
       </p:sp>
@@ -1863,7 +1621,7 @@
             <a:spLocks noGrp="1"/>
           </p:cNvSpPr>
           <p:nvPr>
-            <p:ph type="sldNum" idx="5" sz="quarter"/>
+            <p:ph type="sldNum" sz="quarter" idx="5"/>
           </p:nvPr>
         </p:nvSpPr>
         <p:spPr/>
@@ -1914,10 +1672,9 @@
           <a:lstStyle/>
           <a:p>
             <a:r>
-              <a:rPr lang="en-US" smtClean="0"/>
+              <a:rPr lang="en-US"/>
               <a:t>Click to edit Master title style</a:t>
             </a:r>
-            <a:endParaRPr lang="en-US"/>
           </a:p>
         </p:txBody>
       </p:sp>
@@ -2033,10 +1790,9 @@
           </a:lstStyle>
           <a:p>
             <a:r>
-              <a:rPr lang="en-US" smtClean="0"/>
+              <a:rPr lang="en-US"/>
               <a:t>Click to edit Master subtitle style</a:t>
             </a:r>
-            <a:endParaRPr lang="en-US"/>
           </a:p>
         </p:txBody>
       </p:sp>
@@ -2057,7 +1813,7 @@
           <a:p>
             <a:fld id="{5BCAD085-E8A6-8845-BD4E-CB4CCA059FC4}" type="datetimeFigureOut">
               <a:rPr lang="en-US" smtClean="0"/>
-              <a:t>1/27/13</a:t>
+              <a:t>9/12/2026</a:t>
             </a:fld>
             <a:endParaRPr lang="en-US"/>
           </a:p>
@@ -2099,7 +1855,7 @@
           <a:p>
             <a:fld id="{C1FF6DA9-008F-8B48-92A6-B652298478BF}" type="slidenum">
               <a:rPr lang="en-US" smtClean="0"/>
-              <a:t>‹#›</a:t>
+              <a:t>‹N°›</a:t>
             </a:fld>
             <a:endParaRPr lang="en-US"/>
           </a:p>
@@ -2151,10 +1907,9 @@
           <a:lstStyle/>
           <a:p>
             <a:r>
-              <a:rPr lang="en-US" smtClean="0"/>
+              <a:rPr lang="en-US"/>
               <a:t>Click to edit Master title style</a:t>
             </a:r>
-            <a:endParaRPr lang="en-US"/>
           </a:p>
         </p:txBody>
       </p:sp>
@@ -2175,38 +1930,37 @@
           <a:p>
             <a:pPr lvl="0"/>
             <a:r>
-              <a:rPr lang="en-US" smtClean="0"/>
+              <a:rPr lang="en-US"/>
               <a:t>Click to edit Master text styles</a:t>
             </a:r>
           </a:p>
           <a:p>
             <a:pPr lvl="1"/>
             <a:r>
-              <a:rPr lang="en-US" smtClean="0"/>
+              <a:rPr lang="en-US"/>
               <a:t>Second level</a:t>
             </a:r>
           </a:p>
           <a:p>
             <a:pPr lvl="2"/>
             <a:r>
-              <a:rPr lang="en-US" smtClean="0"/>
+              <a:rPr lang="en-US"/>
               <a:t>Third level</a:t>
             </a:r>
           </a:p>
           <a:p>
             <a:pPr lvl="3"/>
             <a:r>
-              <a:rPr lang="en-US" smtClean="0"/>
+              <a:rPr lang="en-US"/>
               <a:t>Fourth level</a:t>
             </a:r>
           </a:p>
           <a:p>
             <a:pPr lvl="4"/>
             <a:r>
-              <a:rPr lang="en-US" smtClean="0"/>
+              <a:rPr lang="en-US"/>
               <a:t>Fifth level</a:t>
             </a:r>
-            <a:endParaRPr lang="en-US"/>
           </a:p>
         </p:txBody>
       </p:sp>
@@ -2227,7 +1981,7 @@
           <a:p>
             <a:fld id="{5BCAD085-E8A6-8845-BD4E-CB4CCA059FC4}" type="datetimeFigureOut">
               <a:rPr lang="en-US" smtClean="0"/>
-              <a:t>1/27/13</a:t>
+              <a:t>9/12/2026</a:t>
             </a:fld>
             <a:endParaRPr lang="en-US"/>
           </a:p>
@@ -2269,7 +2023,7 @@
           <a:p>
             <a:fld id="{C1FF6DA9-008F-8B48-92A6-B652298478BF}" type="slidenum">
               <a:rPr lang="en-US" smtClean="0"/>
-              <a:t>‹#›</a:t>
+              <a:t>‹N°›</a:t>
             </a:fld>
             <a:endParaRPr lang="en-US"/>
           </a:p>
@@ -2326,10 +2080,9 @@
           <a:lstStyle/>
           <a:p>
             <a:r>
-              <a:rPr lang="en-US" smtClean="0"/>
+              <a:rPr lang="en-US"/>
               <a:t>Click to edit Master title style</a:t>
             </a:r>
-            <a:endParaRPr lang="en-US"/>
           </a:p>
         </p:txBody>
       </p:sp>
@@ -2355,38 +2108,37 @@
           <a:p>
             <a:pPr lvl="0"/>
             <a:r>
-              <a:rPr lang="en-US" smtClean="0"/>
+              <a:rPr lang="en-US"/>
               <a:t>Click to edit Master text styles</a:t>
             </a:r>
           </a:p>
           <a:p>
             <a:pPr lvl="1"/>
             <a:r>
-              <a:rPr lang="en-US" smtClean="0"/>
+              <a:rPr lang="en-US"/>
               <a:t>Second level</a:t>
             </a:r>
           </a:p>
           <a:p>
             <a:pPr lvl="2"/>
             <a:r>
-              <a:rPr lang="en-US" smtClean="0"/>
+              <a:rPr lang="en-US"/>
               <a:t>Third level</a:t>
             </a:r>
           </a:p>
           <a:p>
             <a:pPr lvl="3"/>
             <a:r>
-              <a:rPr lang="en-US" smtClean="0"/>
+              <a:rPr lang="en-US"/>
               <a:t>Fourth level</a:t>
             </a:r>
           </a:p>
           <a:p>
             <a:pPr lvl="4"/>
             <a:r>
-              <a:rPr lang="en-US" smtClean="0"/>
+              <a:rPr lang="en-US"/>
               <a:t>Fifth level</a:t>
             </a:r>
-            <a:endParaRPr lang="en-US"/>
           </a:p>
         </p:txBody>
       </p:sp>
@@ -2407,7 +2159,7 @@
           <a:p>
             <a:fld id="{5BCAD085-E8A6-8845-BD4E-CB4CCA059FC4}" type="datetimeFigureOut">
               <a:rPr lang="en-US" smtClean="0"/>
-              <a:t>1/27/13</a:t>
+              <a:t>9/12/2026</a:t>
             </a:fld>
             <a:endParaRPr lang="en-US"/>
           </a:p>
@@ -2449,7 +2201,7 @@
           <a:p>
             <a:fld id="{C1FF6DA9-008F-8B48-92A6-B652298478BF}" type="slidenum">
               <a:rPr lang="en-US" smtClean="0"/>
-              <a:t>‹#›</a:t>
+              <a:t>‹N°›</a:t>
             </a:fld>
             <a:endParaRPr lang="en-US"/>
           </a:p>
@@ -2501,10 +2253,9 @@
           <a:lstStyle/>
           <a:p>
             <a:r>
-              <a:rPr lang="en-US" smtClean="0"/>
+              <a:rPr lang="en-US"/>
               <a:t>Click to edit Master title style</a:t>
             </a:r>
-            <a:endParaRPr lang="en-US"/>
           </a:p>
         </p:txBody>
       </p:sp>
@@ -2525,38 +2276,37 @@
           <a:p>
             <a:pPr lvl="0"/>
             <a:r>
-              <a:rPr lang="en-US" smtClean="0"/>
+              <a:rPr lang="en-US"/>
               <a:t>Click to edit Master text styles</a:t>
             </a:r>
           </a:p>
           <a:p>
             <a:pPr lvl="1"/>
             <a:r>
-              <a:rPr lang="en-US" smtClean="0"/>
+              <a:rPr lang="en-US"/>
               <a:t>Second level</a:t>
             </a:r>
           </a:p>
           <a:p>
             <a:pPr lvl="2"/>
             <a:r>
-              <a:rPr lang="en-US" smtClean="0"/>
+              <a:rPr lang="en-US"/>
               <a:t>Third level</a:t>
             </a:r>
           </a:p>
           <a:p>
             <a:pPr lvl="3"/>
             <a:r>
-              <a:rPr lang="en-US" smtClean="0"/>
+              <a:rPr lang="en-US"/>
               <a:t>Fourth level</a:t>
             </a:r>
           </a:p>
           <a:p>
             <a:pPr lvl="4"/>
             <a:r>
-              <a:rPr lang="en-US" smtClean="0"/>
+              <a:rPr lang="en-US"/>
               <a:t>Fifth level</a:t>
             </a:r>
-            <a:endParaRPr lang="en-US"/>
           </a:p>
         </p:txBody>
       </p:sp>
@@ -2577,7 +2327,7 @@
           <a:p>
             <a:fld id="{5BCAD085-E8A6-8845-BD4E-CB4CCA059FC4}" type="datetimeFigureOut">
               <a:rPr lang="en-US" smtClean="0"/>
-              <a:t>1/27/13</a:t>
+              <a:t>9/12/2026</a:t>
             </a:fld>
             <a:endParaRPr lang="en-US"/>
           </a:p>
@@ -2619,7 +2369,7 @@
           <a:p>
             <a:fld id="{C1FF6DA9-008F-8B48-92A6-B652298478BF}" type="slidenum">
               <a:rPr lang="en-US" smtClean="0"/>
-              <a:t>‹#›</a:t>
+              <a:t>‹N°›</a:t>
             </a:fld>
             <a:endParaRPr lang="en-US"/>
           </a:p>
@@ -2680,10 +2430,9 @@
           </a:lstStyle>
           <a:p>
             <a:r>
-              <a:rPr lang="en-US" smtClean="0"/>
+              <a:rPr lang="en-US"/>
               <a:t>Click to edit Master title style</a:t>
             </a:r>
-            <a:endParaRPr lang="en-US"/>
           </a:p>
         </p:txBody>
       </p:sp>
@@ -2800,7 +2549,7 @@
           <a:p>
             <a:pPr lvl="0"/>
             <a:r>
-              <a:rPr lang="en-US" smtClean="0"/>
+              <a:rPr lang="en-US"/>
               <a:t>Click to edit Master text styles</a:t>
             </a:r>
           </a:p>
@@ -2823,7 +2572,7 @@
           <a:p>
             <a:fld id="{5BCAD085-E8A6-8845-BD4E-CB4CCA059FC4}" type="datetimeFigureOut">
               <a:rPr lang="en-US" smtClean="0"/>
-              <a:t>1/27/13</a:t>
+              <a:t>9/12/2026</a:t>
             </a:fld>
             <a:endParaRPr lang="en-US"/>
           </a:p>
@@ -2865,7 +2614,7 @@
           <a:p>
             <a:fld id="{C1FF6DA9-008F-8B48-92A6-B652298478BF}" type="slidenum">
               <a:rPr lang="en-US" smtClean="0"/>
-              <a:t>‹#›</a:t>
+              <a:t>‹N°›</a:t>
             </a:fld>
             <a:endParaRPr lang="en-US"/>
           </a:p>
@@ -2917,10 +2666,9 @@
           <a:lstStyle/>
           <a:p>
             <a:r>
-              <a:rPr lang="en-US" smtClean="0"/>
+              <a:rPr lang="en-US"/>
               <a:t>Click to edit Master title style</a:t>
             </a:r>
-            <a:endParaRPr lang="en-US"/>
           </a:p>
         </p:txBody>
       </p:sp>
@@ -2974,38 +2722,37 @@
           <a:p>
             <a:pPr lvl="0"/>
             <a:r>
-              <a:rPr lang="en-US" smtClean="0"/>
+              <a:rPr lang="en-US"/>
               <a:t>Click to edit Master text styles</a:t>
             </a:r>
           </a:p>
           <a:p>
             <a:pPr lvl="1"/>
             <a:r>
-              <a:rPr lang="en-US" smtClean="0"/>
+              <a:rPr lang="en-US"/>
               <a:t>Second level</a:t>
             </a:r>
           </a:p>
           <a:p>
             <a:pPr lvl="2"/>
             <a:r>
-              <a:rPr lang="en-US" smtClean="0"/>
+              <a:rPr lang="en-US"/>
               <a:t>Third level</a:t>
             </a:r>
           </a:p>
           <a:p>
             <a:pPr lvl="3"/>
             <a:r>
-              <a:rPr lang="en-US" smtClean="0"/>
+              <a:rPr lang="en-US"/>
               <a:t>Fourth level</a:t>
             </a:r>
           </a:p>
           <a:p>
             <a:pPr lvl="4"/>
             <a:r>
-              <a:rPr lang="en-US" smtClean="0"/>
+              <a:rPr lang="en-US"/>
               <a:t>Fifth level</a:t>
             </a:r>
-            <a:endParaRPr lang="en-US"/>
           </a:p>
         </p:txBody>
       </p:sp>
@@ -3059,38 +2806,37 @@
           <a:p>
             <a:pPr lvl="0"/>
             <a:r>
-              <a:rPr lang="en-US" smtClean="0"/>
+              <a:rPr lang="en-US"/>
               <a:t>Click to edit Master text styles</a:t>
             </a:r>
           </a:p>
           <a:p>
             <a:pPr lvl="1"/>
             <a:r>
-              <a:rPr lang="en-US" smtClean="0"/>
+              <a:rPr lang="en-US"/>
               <a:t>Second level</a:t>
             </a:r>
           </a:p>
           <a:p>
             <a:pPr lvl="2"/>
             <a:r>
-              <a:rPr lang="en-US" smtClean="0"/>
+              <a:rPr lang="en-US"/>
               <a:t>Third level</a:t>
             </a:r>
           </a:p>
           <a:p>
             <a:pPr lvl="3"/>
             <a:r>
-              <a:rPr lang="en-US" smtClean="0"/>
+              <a:rPr lang="en-US"/>
               <a:t>Fourth level</a:t>
             </a:r>
           </a:p>
           <a:p>
             <a:pPr lvl="4"/>
             <a:r>
-              <a:rPr lang="en-US" smtClean="0"/>
+              <a:rPr lang="en-US"/>
               <a:t>Fifth level</a:t>
             </a:r>
-            <a:endParaRPr lang="en-US"/>
           </a:p>
         </p:txBody>
       </p:sp>
@@ -3111,7 +2857,7 @@
           <a:p>
             <a:fld id="{5BCAD085-E8A6-8845-BD4E-CB4CCA059FC4}" type="datetimeFigureOut">
               <a:rPr lang="en-US" smtClean="0"/>
-              <a:t>1/27/13</a:t>
+              <a:t>9/12/2026</a:t>
             </a:fld>
             <a:endParaRPr lang="en-US"/>
           </a:p>
@@ -3153,7 +2899,7 @@
           <a:p>
             <a:fld id="{C1FF6DA9-008F-8B48-92A6-B652298478BF}" type="slidenum">
               <a:rPr lang="en-US" smtClean="0"/>
-              <a:t>‹#›</a:t>
+              <a:t>‹N°›</a:t>
             </a:fld>
             <a:endParaRPr lang="en-US"/>
           </a:p>
@@ -3209,10 +2955,9 @@
           </a:lstStyle>
           <a:p>
             <a:r>
-              <a:rPr lang="en-US" smtClean="0"/>
+              <a:rPr lang="en-US"/>
               <a:t>Click to edit Master title style</a:t>
             </a:r>
-            <a:endParaRPr lang="en-US"/>
           </a:p>
         </p:txBody>
       </p:sp>
@@ -3275,7 +3020,7 @@
           <a:p>
             <a:pPr lvl="0"/>
             <a:r>
-              <a:rPr lang="en-US" smtClean="0"/>
+              <a:rPr lang="en-US"/>
               <a:t>Click to edit Master text styles</a:t>
             </a:r>
           </a:p>
@@ -3331,38 +3076,37 @@
           <a:p>
             <a:pPr lvl="0"/>
             <a:r>
-              <a:rPr lang="en-US" smtClean="0"/>
+              <a:rPr lang="en-US"/>
               <a:t>Click to edit Master text styles</a:t>
             </a:r>
           </a:p>
           <a:p>
             <a:pPr lvl="1"/>
             <a:r>
-              <a:rPr lang="en-US" smtClean="0"/>
+              <a:rPr lang="en-US"/>
               <a:t>Second level</a:t>
             </a:r>
           </a:p>
           <a:p>
             <a:pPr lvl="2"/>
             <a:r>
-              <a:rPr lang="en-US" smtClean="0"/>
+              <a:rPr lang="en-US"/>
               <a:t>Third level</a:t>
             </a:r>
           </a:p>
           <a:p>
             <a:pPr lvl="3"/>
             <a:r>
-              <a:rPr lang="en-US" smtClean="0"/>
+              <a:rPr lang="en-US"/>
               <a:t>Fourth level</a:t>
             </a:r>
           </a:p>
           <a:p>
             <a:pPr lvl="4"/>
             <a:r>
-              <a:rPr lang="en-US" smtClean="0"/>
+              <a:rPr lang="en-US"/>
               <a:t>Fifth level</a:t>
             </a:r>
-            <a:endParaRPr lang="en-US"/>
           </a:p>
         </p:txBody>
       </p:sp>
@@ -3425,7 +3169,7 @@
           <a:p>
             <a:pPr lvl="0"/>
             <a:r>
-              <a:rPr lang="en-US" smtClean="0"/>
+              <a:rPr lang="en-US"/>
               <a:t>Click to edit Master text styles</a:t>
             </a:r>
           </a:p>
@@ -3481,38 +3225,37 @@
           <a:p>
             <a:pPr lvl="0"/>
             <a:r>
-              <a:rPr lang="en-US" smtClean="0"/>
+              <a:rPr lang="en-US"/>
               <a:t>Click to edit Master text styles</a:t>
             </a:r>
           </a:p>
           <a:p>
             <a:pPr lvl="1"/>
             <a:r>
-              <a:rPr lang="en-US" smtClean="0"/>
+              <a:rPr lang="en-US"/>
               <a:t>Second level</a:t>
             </a:r>
           </a:p>
           <a:p>
             <a:pPr lvl="2"/>
             <a:r>
-              <a:rPr lang="en-US" smtClean="0"/>
+              <a:rPr lang="en-US"/>
               <a:t>Third level</a:t>
             </a:r>
           </a:p>
           <a:p>
             <a:pPr lvl="3"/>
             <a:r>
-              <a:rPr lang="en-US" smtClean="0"/>
+              <a:rPr lang="en-US"/>
               <a:t>Fourth level</a:t>
             </a:r>
           </a:p>
           <a:p>
             <a:pPr lvl="4"/>
             <a:r>
-              <a:rPr lang="en-US" smtClean="0"/>
+              <a:rPr lang="en-US"/>
               <a:t>Fifth level</a:t>
             </a:r>
-            <a:endParaRPr lang="en-US"/>
           </a:p>
         </p:txBody>
       </p:sp>
@@ -3533,7 +3276,7 @@
           <a:p>
             <a:fld id="{5BCAD085-E8A6-8845-BD4E-CB4CCA059FC4}" type="datetimeFigureOut">
               <a:rPr lang="en-US" smtClean="0"/>
-              <a:t>1/27/13</a:t>
+              <a:t>9/12/2026</a:t>
             </a:fld>
             <a:endParaRPr lang="en-US"/>
           </a:p>
@@ -3575,7 +3318,7 @@
           <a:p>
             <a:fld id="{C1FF6DA9-008F-8B48-92A6-B652298478BF}" type="slidenum">
               <a:rPr lang="en-US" smtClean="0"/>
-              <a:t>‹#›</a:t>
+              <a:t>‹N°›</a:t>
             </a:fld>
             <a:endParaRPr lang="en-US"/>
           </a:p>
@@ -3627,10 +3370,9 @@
           <a:lstStyle/>
           <a:p>
             <a:r>
-              <a:rPr lang="en-US" smtClean="0"/>
+              <a:rPr lang="en-US"/>
               <a:t>Click to edit Master title style</a:t>
             </a:r>
-            <a:endParaRPr lang="en-US"/>
           </a:p>
         </p:txBody>
       </p:sp>
@@ -3651,7 +3393,7 @@
           <a:p>
             <a:fld id="{5BCAD085-E8A6-8845-BD4E-CB4CCA059FC4}" type="datetimeFigureOut">
               <a:rPr lang="en-US" smtClean="0"/>
-              <a:t>1/27/13</a:t>
+              <a:t>9/12/2026</a:t>
             </a:fld>
             <a:endParaRPr lang="en-US"/>
           </a:p>
@@ -3693,7 +3435,7 @@
           <a:p>
             <a:fld id="{C1FF6DA9-008F-8B48-92A6-B652298478BF}" type="slidenum">
               <a:rPr lang="en-US" smtClean="0"/>
-              <a:t>‹#›</a:t>
+              <a:t>‹N°›</a:t>
             </a:fld>
             <a:endParaRPr lang="en-US"/>
           </a:p>
@@ -3746,7 +3488,7 @@
           <a:p>
             <a:fld id="{5BCAD085-E8A6-8845-BD4E-CB4CCA059FC4}" type="datetimeFigureOut">
               <a:rPr lang="en-US" smtClean="0"/>
-              <a:t>1/27/13</a:t>
+              <a:t>9/12/2026</a:t>
             </a:fld>
             <a:endParaRPr lang="en-US"/>
           </a:p>
@@ -3788,7 +3530,7 @@
           <a:p>
             <a:fld id="{C1FF6DA9-008F-8B48-92A6-B652298478BF}" type="slidenum">
               <a:rPr lang="en-US" smtClean="0"/>
-              <a:t>‹#›</a:t>
+              <a:t>‹N°›</a:t>
             </a:fld>
             <a:endParaRPr lang="en-US"/>
           </a:p>
@@ -3849,10 +3591,9 @@
           </a:lstStyle>
           <a:p>
             <a:r>
-              <a:rPr lang="en-US" smtClean="0"/>
+              <a:rPr lang="en-US"/>
               <a:t>Click to edit Master title style</a:t>
             </a:r>
-            <a:endParaRPr lang="en-US"/>
           </a:p>
         </p:txBody>
       </p:sp>
@@ -3906,38 +3647,37 @@
           <a:p>
             <a:pPr lvl="0"/>
             <a:r>
-              <a:rPr lang="en-US" smtClean="0"/>
+              <a:rPr lang="en-US"/>
               <a:t>Click to edit Master text styles</a:t>
             </a:r>
           </a:p>
           <a:p>
             <a:pPr lvl="1"/>
             <a:r>
-              <a:rPr lang="en-US" smtClean="0"/>
+              <a:rPr lang="en-US"/>
               <a:t>Second level</a:t>
             </a:r>
           </a:p>
           <a:p>
             <a:pPr lvl="2"/>
             <a:r>
-              <a:rPr lang="en-US" smtClean="0"/>
+              <a:rPr lang="en-US"/>
               <a:t>Third level</a:t>
             </a:r>
           </a:p>
           <a:p>
             <a:pPr lvl="3"/>
             <a:r>
-              <a:rPr lang="en-US" smtClean="0"/>
+              <a:rPr lang="en-US"/>
               <a:t>Fourth level</a:t>
             </a:r>
           </a:p>
           <a:p>
             <a:pPr lvl="4"/>
             <a:r>
-              <a:rPr lang="en-US" smtClean="0"/>
+              <a:rPr lang="en-US"/>
               <a:t>Fifth level</a:t>
             </a:r>
-            <a:endParaRPr lang="en-US"/>
           </a:p>
         </p:txBody>
       </p:sp>
@@ -4000,7 +3740,7 @@
           <a:p>
             <a:pPr lvl="0"/>
             <a:r>
-              <a:rPr lang="en-US" smtClean="0"/>
+              <a:rPr lang="en-US"/>
               <a:t>Click to edit Master text styles</a:t>
             </a:r>
           </a:p>
@@ -4023,7 +3763,7 @@
           <a:p>
             <a:fld id="{5BCAD085-E8A6-8845-BD4E-CB4CCA059FC4}" type="datetimeFigureOut">
               <a:rPr lang="en-US" smtClean="0"/>
-              <a:t>1/27/13</a:t>
+              <a:t>9/12/2026</a:t>
             </a:fld>
             <a:endParaRPr lang="en-US"/>
           </a:p>
@@ -4065,7 +3805,7 @@
           <a:p>
             <a:fld id="{C1FF6DA9-008F-8B48-92A6-B652298478BF}" type="slidenum">
               <a:rPr lang="en-US" smtClean="0"/>
-              <a:t>‹#›</a:t>
+              <a:t>‹N°›</a:t>
             </a:fld>
             <a:endParaRPr lang="en-US"/>
           </a:p>
@@ -4126,10 +3866,9 @@
           </a:lstStyle>
           <a:p>
             <a:r>
-              <a:rPr lang="en-US" smtClean="0"/>
+              <a:rPr lang="en-US"/>
               <a:t>Click to edit Master title style</a:t>
             </a:r>
-            <a:endParaRPr lang="en-US"/>
           </a:p>
         </p:txBody>
       </p:sp>
@@ -4253,7 +3992,7 @@
           <a:p>
             <a:pPr lvl="0"/>
             <a:r>
-              <a:rPr lang="en-US" smtClean="0"/>
+              <a:rPr lang="en-US"/>
               <a:t>Click to edit Master text styles</a:t>
             </a:r>
           </a:p>
@@ -4276,7 +4015,7 @@
           <a:p>
             <a:fld id="{5BCAD085-E8A6-8845-BD4E-CB4CCA059FC4}" type="datetimeFigureOut">
               <a:rPr lang="en-US" smtClean="0"/>
-              <a:t>1/27/13</a:t>
+              <a:t>9/12/2026</a:t>
             </a:fld>
             <a:endParaRPr lang="en-US"/>
           </a:p>
@@ -4318,7 +4057,7 @@
           <a:p>
             <a:fld id="{C1FF6DA9-008F-8B48-92A6-B652298478BF}" type="slidenum">
               <a:rPr lang="en-US" smtClean="0"/>
-              <a:t>‹#›</a:t>
+              <a:t>‹N°›</a:t>
             </a:fld>
             <a:endParaRPr lang="en-US"/>
           </a:p>
@@ -4385,10 +4124,9 @@
           <a:lstStyle/>
           <a:p>
             <a:r>
-              <a:rPr lang="en-US" smtClean="0"/>
+              <a:rPr lang="en-US"/>
               <a:t>Click to edit Master title style</a:t>
             </a:r>
-            <a:endParaRPr lang="en-US"/>
           </a:p>
         </p:txBody>
       </p:sp>
@@ -4419,38 +4157,37 @@
           <a:p>
             <a:pPr lvl="0"/>
             <a:r>
-              <a:rPr lang="en-US" smtClean="0"/>
+              <a:rPr lang="en-US"/>
               <a:t>Click to edit Master text styles</a:t>
             </a:r>
           </a:p>
           <a:p>
             <a:pPr lvl="1"/>
             <a:r>
-              <a:rPr lang="en-US" smtClean="0"/>
+              <a:rPr lang="en-US"/>
               <a:t>Second level</a:t>
             </a:r>
           </a:p>
           <a:p>
             <a:pPr lvl="2"/>
             <a:r>
-              <a:rPr lang="en-US" smtClean="0"/>
+              <a:rPr lang="en-US"/>
               <a:t>Third level</a:t>
             </a:r>
           </a:p>
           <a:p>
             <a:pPr lvl="3"/>
             <a:r>
-              <a:rPr lang="en-US" smtClean="0"/>
+              <a:rPr lang="en-US"/>
               <a:t>Fourth level</a:t>
             </a:r>
           </a:p>
           <a:p>
             <a:pPr lvl="4"/>
             <a:r>
-              <a:rPr lang="en-US" smtClean="0"/>
+              <a:rPr lang="en-US"/>
               <a:t>Fifth level</a:t>
             </a:r>
-            <a:endParaRPr lang="en-US"/>
           </a:p>
         </p:txBody>
       </p:sp>
@@ -4489,7 +4226,7 @@
           <a:p>
             <a:fld id="{5BCAD085-E8A6-8845-BD4E-CB4CCA059FC4}" type="datetimeFigureOut">
               <a:rPr lang="en-US" smtClean="0"/>
-              <a:t>1/27/13</a:t>
+              <a:t>9/12/2026</a:t>
             </a:fld>
             <a:endParaRPr lang="en-US"/>
           </a:p>
@@ -4567,7 +4304,7 @@
           <a:p>
             <a:fld id="{C1FF6DA9-008F-8B48-92A6-B652298478BF}" type="slidenum">
               <a:rPr lang="en-US" smtClean="0"/>
-              <a:t>‹#›</a:t>
+              <a:t>‹N°›</a:t>
             </a:fld>
             <a:endParaRPr lang="en-US"/>
           </a:p>
@@ -4848,7 +4585,7 @@
 </file>
 
 <file path=ppt/slides/slide1.xml><?xml version="1.0" encoding="utf-8"?>
-<p:sld xmlns:a="http://schemas.openxmlformats.org/drawingml/2006/main" xmlns:p="http://schemas.openxmlformats.org/presentationml/2006/main" xmlns:r="http://schemas.openxmlformats.org/officeDocument/2006/relationships">
+<p:sld xmlns:a="http://schemas.openxmlformats.org/drawingml/2006/main" xmlns:r="http://schemas.openxmlformats.org/officeDocument/2006/relationships" xmlns:p="http://schemas.openxmlformats.org/presentationml/2006/main">
   <p:cSld>
     <p:spTree>
       <p:nvGrpSpPr>
@@ -4856,7 +4593,14 @@
         <p:cNvGrpSpPr/>
         <p:nvPr/>
       </p:nvGrpSpPr>
-      <p:grpSpPr/>
+      <p:grpSpPr>
+        <a:xfrm>
+          <a:off x="0" y="0"/>
+          <a:ext cx="0" cy="0"/>
+          <a:chOff x="0" y="0"/>
+          <a:chExt cx="0" cy="0"/>
+        </a:xfrm>
+      </p:grpSpPr>
       <p:sp>
         <p:nvSpPr>
           <p:cNvPr id="2" name="TextBox 1"/>
@@ -4883,7 +4627,9 @@
             <a:spAutoFit/>
           </a:bodyPr>
           <a:lstStyle/>
-          <a:p/>
+          <a:p>
+            <a:endParaRPr/>
+          </a:p>
         </p:txBody>
       </p:sp>
       <p:sp>
@@ -4910,14 +4656,92 @@
           <a:p>
             <a:pPr algn="l"/>
             <a:r>
-              <a:rPr sz="3400" b="1">
+              <a:rPr sz="3400" b="1" dirty="0" err="1">
                 <a:solidFill>
                   <a:srgbClr val="FFFFFF"/>
                 </a:solidFill>
                 <a:latin typeface="Calibri"/>
               </a:rPr>
-              <a:t>Plateforme ELT Eckert — détecter les contrats en déshérence</a:t>
-            </a:r>
+              <a:t>Plateforme</a:t>
+            </a:r>
+            <a:r>
+              <a:rPr sz="3400" b="1" dirty="0">
+                <a:solidFill>
+                  <a:srgbClr val="FFFFFF"/>
+                </a:solidFill>
+                <a:latin typeface="Calibri"/>
+              </a:rPr>
+              <a:t> ELT Eckert — </a:t>
+            </a:r>
+            <a:r>
+              <a:rPr sz="3400" b="1" dirty="0" err="1">
+                <a:solidFill>
+                  <a:srgbClr val="FFFFFF"/>
+                </a:solidFill>
+                <a:latin typeface="Calibri"/>
+              </a:rPr>
+              <a:t>détecter</a:t>
+            </a:r>
+            <a:r>
+              <a:rPr sz="3400" b="1" dirty="0">
+                <a:solidFill>
+                  <a:srgbClr val="FFFFFF"/>
+                </a:solidFill>
+                <a:latin typeface="Calibri"/>
+              </a:rPr>
+              <a:t> les </a:t>
+            </a:r>
+            <a:r>
+              <a:rPr sz="3400" b="1" dirty="0" err="1">
+                <a:solidFill>
+                  <a:srgbClr val="FFFFFF"/>
+                </a:solidFill>
+                <a:latin typeface="Calibri"/>
+              </a:rPr>
+              <a:t>contrats</a:t>
+            </a:r>
+            <a:r>
+              <a:rPr sz="3400" b="1" dirty="0">
+                <a:solidFill>
+                  <a:srgbClr val="FFFFFF"/>
+                </a:solidFill>
+                <a:latin typeface="Calibri"/>
+              </a:rPr>
+              <a:t> </a:t>
+            </a:r>
+            <a:r>
+              <a:rPr sz="3400" b="1" dirty="0" err="1">
+                <a:solidFill>
+                  <a:srgbClr val="FFFFFF"/>
+                </a:solidFill>
+                <a:latin typeface="Calibri"/>
+              </a:rPr>
+              <a:t>en</a:t>
+            </a:r>
+            <a:r>
+              <a:rPr sz="3400" b="1" dirty="0">
+                <a:solidFill>
+                  <a:srgbClr val="FFFFFF"/>
+                </a:solidFill>
+                <a:latin typeface="Calibri"/>
+              </a:rPr>
+              <a:t> </a:t>
+            </a:r>
+            <a:r>
+              <a:rPr sz="3400" b="1" dirty="0" err="1">
+                <a:solidFill>
+                  <a:srgbClr val="FFFFFF"/>
+                </a:solidFill>
+                <a:latin typeface="Calibri"/>
+              </a:rPr>
+              <a:t>déshérence</a:t>
+            </a:r>
+            <a:endParaRPr sz="3400" b="1" dirty="0">
+              <a:solidFill>
+                <a:srgbClr val="FFFFFF"/>
+              </a:solidFill>
+              <a:latin typeface="Calibri"/>
+            </a:endParaRPr>
           </a:p>
         </p:txBody>
       </p:sp>
@@ -4929,8 +4753,8 @@
         </p:nvSpPr>
         <p:spPr>
           <a:xfrm>
-            <a:off x="700000" y="3900000"/>
-            <a:ext cx="10800000" cy="1000000"/>
+            <a:off x="696000" y="3900000"/>
+            <a:ext cx="10800000" cy="2800767"/>
           </a:xfrm>
           <a:prstGeom prst="rect">
             <a:avLst/>
@@ -4945,13 +4769,85 @@
           <a:p>
             <a:pPr algn="l"/>
             <a:r>
-              <a:rPr sz="2200" b="0">
+              <a:rPr sz="2200" b="0" dirty="0">
                 <a:solidFill>
                   <a:srgbClr val="E8ECF0"/>
                 </a:solidFill>
                 <a:latin typeface="Calibri"/>
               </a:rPr>
               <a:t>Bloc 4 · Spécialité Data Engineer · RNCP 39586</a:t>
+            </a:r>
+            <a:endParaRPr lang="fr-FR" sz="2200" b="0" dirty="0">
+              <a:solidFill>
+                <a:srgbClr val="E8ECF0"/>
+              </a:solidFill>
+              <a:latin typeface="Calibri"/>
+            </a:endParaRPr>
+          </a:p>
+          <a:p>
+            <a:pPr algn="l"/>
+            <a:endParaRPr lang="fr-FR" sz="2200" dirty="0">
+              <a:solidFill>
+                <a:srgbClr val="E8ECF0"/>
+              </a:solidFill>
+              <a:latin typeface="Calibri"/>
+            </a:endParaRPr>
+          </a:p>
+          <a:p>
+            <a:pPr algn="l"/>
+            <a:endParaRPr lang="fr-FR" sz="2200" b="0" dirty="0">
+              <a:solidFill>
+                <a:srgbClr val="E8ECF0"/>
+              </a:solidFill>
+              <a:latin typeface="Calibri"/>
+            </a:endParaRPr>
+          </a:p>
+          <a:p>
+            <a:pPr algn="l"/>
+            <a:endParaRPr lang="fr-FR" sz="2200" dirty="0">
+              <a:solidFill>
+                <a:srgbClr val="E8ECF0"/>
+              </a:solidFill>
+              <a:latin typeface="Calibri"/>
+            </a:endParaRPr>
+          </a:p>
+          <a:p>
+            <a:pPr algn="l"/>
+            <a:endParaRPr lang="fr-FR" sz="2200" b="0" dirty="0">
+              <a:solidFill>
+                <a:srgbClr val="E8ECF0"/>
+              </a:solidFill>
+              <a:latin typeface="Calibri"/>
+            </a:endParaRPr>
+          </a:p>
+          <a:p>
+            <a:pPr algn="l"/>
+            <a:endParaRPr lang="fr-FR" sz="2200" dirty="0">
+              <a:solidFill>
+                <a:srgbClr val="E8ECF0"/>
+              </a:solidFill>
+              <a:latin typeface="Calibri"/>
+            </a:endParaRPr>
+          </a:p>
+          <a:p>
+            <a:pPr algn="l"/>
+            <a:endParaRPr lang="fr-FR" sz="2200" b="0" dirty="0">
+              <a:solidFill>
+                <a:srgbClr val="E8ECF0"/>
+              </a:solidFill>
+              <a:latin typeface="Calibri"/>
+            </a:endParaRPr>
+          </a:p>
+          <a:p>
+            <a:pPr algn="l"/>
+            <a:r>
+              <a:rPr lang="fr-FR" sz="1600" b="0" dirty="0">
+                <a:solidFill>
+                  <a:srgbClr val="E8ECF0"/>
+                </a:solidFill>
+                <a:latin typeface="Calibri"/>
+              </a:rPr>
+              <a:t>Emmanuel Jovanovic</a:t>
             </a:r>
           </a:p>
         </p:txBody>
@@ -4965,7 +4861,7 @@
 </file>
 
 <file path=ppt/slides/slide10.xml><?xml version="1.0" encoding="utf-8"?>
-<p:sld xmlns:a="http://schemas.openxmlformats.org/drawingml/2006/main" xmlns:p="http://schemas.openxmlformats.org/presentationml/2006/main" xmlns:r="http://schemas.openxmlformats.org/officeDocument/2006/relationships">
+<p:sld xmlns:a="http://schemas.openxmlformats.org/drawingml/2006/main" xmlns:r="http://schemas.openxmlformats.org/officeDocument/2006/relationships" xmlns:p="http://schemas.openxmlformats.org/presentationml/2006/main">
   <p:cSld>
     <p:spTree>
       <p:nvGrpSpPr>
@@ -4973,7 +4869,14 @@
         <p:cNvGrpSpPr/>
         <p:nvPr/>
       </p:nvGrpSpPr>
-      <p:grpSpPr/>
+      <p:grpSpPr>
+        <a:xfrm>
+          <a:off x="0" y="0"/>
+          <a:ext cx="0" cy="0"/>
+          <a:chOff x="0" y="0"/>
+          <a:chExt cx="0" cy="0"/>
+        </a:xfrm>
+      </p:grpSpPr>
       <p:sp>
         <p:nvSpPr>
           <p:cNvPr id="2" name="TextBox 1"/>
@@ -5097,7 +5000,7 @@
           <p:nvPr/>
         </p:nvPicPr>
         <p:blipFill>
-          <a:blip r:embed="rId2"/>
+          <a:blip r:embed="rId3"/>
           <a:stretch>
             <a:fillRect/>
           </a:stretch>
@@ -5121,7 +5024,7 @@
 </file>
 
 <file path=ppt/slides/slide11.xml><?xml version="1.0" encoding="utf-8"?>
-<p:sld xmlns:a="http://schemas.openxmlformats.org/drawingml/2006/main" xmlns:p="http://schemas.openxmlformats.org/presentationml/2006/main" xmlns:r="http://schemas.openxmlformats.org/officeDocument/2006/relationships">
+<p:sld xmlns:a="http://schemas.openxmlformats.org/drawingml/2006/main" xmlns:r="http://schemas.openxmlformats.org/officeDocument/2006/relationships" xmlns:p="http://schemas.openxmlformats.org/presentationml/2006/main">
   <p:cSld>
     <p:spTree>
       <p:nvGrpSpPr>
@@ -5129,7 +5032,14 @@
         <p:cNvGrpSpPr/>
         <p:nvPr/>
       </p:nvGrpSpPr>
-      <p:grpSpPr/>
+      <p:grpSpPr>
+        <a:xfrm>
+          <a:off x="0" y="0"/>
+          <a:ext cx="0" cy="0"/>
+          <a:chOff x="0" y="0"/>
+          <a:chExt cx="0" cy="0"/>
+        </a:xfrm>
+      </p:grpSpPr>
       <p:sp>
         <p:nvSpPr>
           <p:cNvPr id="2" name="TextBox 1"/>
@@ -5253,7 +5163,7 @@
           <p:nvPr/>
         </p:nvPicPr>
         <p:blipFill>
-          <a:blip r:embed="rId2"/>
+          <a:blip r:embed="rId3"/>
           <a:stretch>
             <a:fillRect/>
           </a:stretch>
@@ -5277,7 +5187,7 @@
 </file>
 
 <file path=ppt/slides/slide12.xml><?xml version="1.0" encoding="utf-8"?>
-<p:sld xmlns:a="http://schemas.openxmlformats.org/drawingml/2006/main" xmlns:p="http://schemas.openxmlformats.org/presentationml/2006/main" xmlns:r="http://schemas.openxmlformats.org/officeDocument/2006/relationships">
+<p:sld xmlns:a="http://schemas.openxmlformats.org/drawingml/2006/main" xmlns:r="http://schemas.openxmlformats.org/officeDocument/2006/relationships" xmlns:p="http://schemas.openxmlformats.org/presentationml/2006/main">
   <p:cSld>
     <p:spTree>
       <p:nvGrpSpPr>
@@ -5285,7 +5195,14 @@
         <p:cNvGrpSpPr/>
         <p:nvPr/>
       </p:nvGrpSpPr>
-      <p:grpSpPr/>
+      <p:grpSpPr>
+        <a:xfrm>
+          <a:off x="0" y="0"/>
+          <a:ext cx="0" cy="0"/>
+          <a:chOff x="0" y="0"/>
+          <a:chExt cx="0" cy="0"/>
+        </a:xfrm>
+      </p:grpSpPr>
       <p:sp>
         <p:nvSpPr>
           <p:cNvPr id="2" name="TextBox 1"/>
@@ -5409,7 +5326,7 @@
           <p:nvPr/>
         </p:nvPicPr>
         <p:blipFill>
-          <a:blip r:embed="rId2"/>
+          <a:blip r:embed="rId3"/>
           <a:stretch>
             <a:fillRect/>
           </a:stretch>
@@ -5433,7 +5350,7 @@
 </file>
 
 <file path=ppt/slides/slide13.xml><?xml version="1.0" encoding="utf-8"?>
-<p:sld xmlns:a="http://schemas.openxmlformats.org/drawingml/2006/main" xmlns:p="http://schemas.openxmlformats.org/presentationml/2006/main" xmlns:r="http://schemas.openxmlformats.org/officeDocument/2006/relationships">
+<p:sld xmlns:a="http://schemas.openxmlformats.org/drawingml/2006/main" xmlns:r="http://schemas.openxmlformats.org/officeDocument/2006/relationships" xmlns:p="http://schemas.openxmlformats.org/presentationml/2006/main">
   <p:cSld>
     <p:spTree>
       <p:nvGrpSpPr>
@@ -5441,7 +5358,14 @@
         <p:cNvGrpSpPr/>
         <p:nvPr/>
       </p:nvGrpSpPr>
-      <p:grpSpPr/>
+      <p:grpSpPr>
+        <a:xfrm>
+          <a:off x="0" y="0"/>
+          <a:ext cx="0" cy="0"/>
+          <a:chOff x="0" y="0"/>
+          <a:chExt cx="0" cy="0"/>
+        </a:xfrm>
+      </p:grpSpPr>
       <p:sp>
         <p:nvSpPr>
           <p:cNvPr id="2" name="TextBox 1"/>
@@ -5597,7 +5521,7 @@
 </file>
 
 <file path=ppt/slides/slide14.xml><?xml version="1.0" encoding="utf-8"?>
-<p:sld xmlns:a="http://schemas.openxmlformats.org/drawingml/2006/main" xmlns:p="http://schemas.openxmlformats.org/presentationml/2006/main" xmlns:r="http://schemas.openxmlformats.org/officeDocument/2006/relationships">
+<p:sld xmlns:a="http://schemas.openxmlformats.org/drawingml/2006/main" xmlns:r="http://schemas.openxmlformats.org/officeDocument/2006/relationships" xmlns:p="http://schemas.openxmlformats.org/presentationml/2006/main">
   <p:cSld>
     <p:spTree>
       <p:nvGrpSpPr>
@@ -5605,7 +5529,14 @@
         <p:cNvGrpSpPr/>
         <p:nvPr/>
       </p:nvGrpSpPr>
-      <p:grpSpPr/>
+      <p:grpSpPr>
+        <a:xfrm>
+          <a:off x="0" y="0"/>
+          <a:ext cx="0" cy="0"/>
+          <a:chOff x="0" y="0"/>
+          <a:chExt cx="0" cy="0"/>
+        </a:xfrm>
+      </p:grpSpPr>
       <p:sp>
         <p:nvSpPr>
           <p:cNvPr id="2" name="TextBox 1"/>
@@ -5761,7 +5692,7 @@
 </file>
 
 <file path=ppt/slides/slide15.xml><?xml version="1.0" encoding="utf-8"?>
-<p:sld xmlns:a="http://schemas.openxmlformats.org/drawingml/2006/main" xmlns:p="http://schemas.openxmlformats.org/presentationml/2006/main" xmlns:r="http://schemas.openxmlformats.org/officeDocument/2006/relationships">
+<p:sld xmlns:a="http://schemas.openxmlformats.org/drawingml/2006/main" xmlns:r="http://schemas.openxmlformats.org/officeDocument/2006/relationships" xmlns:p="http://schemas.openxmlformats.org/presentationml/2006/main">
   <p:cSld>
     <p:spTree>
       <p:nvGrpSpPr>
@@ -5769,7 +5700,14 @@
         <p:cNvGrpSpPr/>
         <p:nvPr/>
       </p:nvGrpSpPr>
-      <p:grpSpPr/>
+      <p:grpSpPr>
+        <a:xfrm>
+          <a:off x="0" y="0"/>
+          <a:ext cx="0" cy="0"/>
+          <a:chOff x="0" y="0"/>
+          <a:chExt cx="0" cy="0"/>
+        </a:xfrm>
+      </p:grpSpPr>
       <p:sp>
         <p:nvSpPr>
           <p:cNvPr id="2" name="TextBox 1"/>
@@ -5925,7 +5863,7 @@
 </file>
 
 <file path=ppt/slides/slide16.xml><?xml version="1.0" encoding="utf-8"?>
-<p:sld xmlns:a="http://schemas.openxmlformats.org/drawingml/2006/main" xmlns:p="http://schemas.openxmlformats.org/presentationml/2006/main" xmlns:r="http://schemas.openxmlformats.org/officeDocument/2006/relationships">
+<p:sld xmlns:a="http://schemas.openxmlformats.org/drawingml/2006/main" xmlns:r="http://schemas.openxmlformats.org/officeDocument/2006/relationships" xmlns:p="http://schemas.openxmlformats.org/presentationml/2006/main">
   <p:cSld>
     <p:spTree>
       <p:nvGrpSpPr>
@@ -5933,7 +5871,14 @@
         <p:cNvGrpSpPr/>
         <p:nvPr/>
       </p:nvGrpSpPr>
-      <p:grpSpPr/>
+      <p:grpSpPr>
+        <a:xfrm>
+          <a:off x="0" y="0"/>
+          <a:ext cx="0" cy="0"/>
+          <a:chOff x="0" y="0"/>
+          <a:chExt cx="0" cy="0"/>
+        </a:xfrm>
+      </p:grpSpPr>
       <p:sp>
         <p:nvSpPr>
           <p:cNvPr id="2" name="TextBox 1"/>
@@ -6089,7 +6034,7 @@
 </file>
 
 <file path=ppt/slides/slide17.xml><?xml version="1.0" encoding="utf-8"?>
-<p:sld xmlns:a="http://schemas.openxmlformats.org/drawingml/2006/main" xmlns:p="http://schemas.openxmlformats.org/presentationml/2006/main" xmlns:r="http://schemas.openxmlformats.org/officeDocument/2006/relationships">
+<p:sld xmlns:a="http://schemas.openxmlformats.org/drawingml/2006/main" xmlns:r="http://schemas.openxmlformats.org/officeDocument/2006/relationships" xmlns:p="http://schemas.openxmlformats.org/presentationml/2006/main">
   <p:cSld>
     <p:spTree>
       <p:nvGrpSpPr>
@@ -6097,7 +6042,14 @@
         <p:cNvGrpSpPr/>
         <p:nvPr/>
       </p:nvGrpSpPr>
-      <p:grpSpPr/>
+      <p:grpSpPr>
+        <a:xfrm>
+          <a:off x="0" y="0"/>
+          <a:ext cx="0" cy="0"/>
+          <a:chOff x="0" y="0"/>
+          <a:chExt cx="0" cy="0"/>
+        </a:xfrm>
+      </p:grpSpPr>
       <p:sp>
         <p:nvSpPr>
           <p:cNvPr id="2" name="TextBox 1"/>
@@ -6269,7 +6221,7 @@
 </file>
 
 <file path=ppt/slides/slide18.xml><?xml version="1.0" encoding="utf-8"?>
-<p:sld xmlns:a="http://schemas.openxmlformats.org/drawingml/2006/main" xmlns:p="http://schemas.openxmlformats.org/presentationml/2006/main" xmlns:r="http://schemas.openxmlformats.org/officeDocument/2006/relationships" show="0">
+<p:sld xmlns:a="http://schemas.openxmlformats.org/drawingml/2006/main" xmlns:r="http://schemas.openxmlformats.org/officeDocument/2006/relationships" xmlns:p="http://schemas.openxmlformats.org/presentationml/2006/main" show="0">
   <p:cSld>
     <p:spTree>
       <p:nvGrpSpPr>
@@ -6277,7 +6229,14 @@
         <p:cNvGrpSpPr/>
         <p:nvPr/>
       </p:nvGrpSpPr>
-      <p:grpSpPr/>
+      <p:grpSpPr>
+        <a:xfrm>
+          <a:off x="0" y="0"/>
+          <a:ext cx="0" cy="0"/>
+          <a:chOff x="0" y="0"/>
+          <a:chExt cx="0" cy="0"/>
+        </a:xfrm>
+      </p:grpSpPr>
       <p:sp>
         <p:nvSpPr>
           <p:cNvPr id="2" name="TextBox 1"/>
@@ -6417,7 +6376,7 @@
 </file>
 
 <file path=ppt/slides/slide19.xml><?xml version="1.0" encoding="utf-8"?>
-<p:sld xmlns:a="http://schemas.openxmlformats.org/drawingml/2006/main" xmlns:p="http://schemas.openxmlformats.org/presentationml/2006/main" xmlns:r="http://schemas.openxmlformats.org/officeDocument/2006/relationships" show="0">
+<p:sld xmlns:a="http://schemas.openxmlformats.org/drawingml/2006/main" xmlns:r="http://schemas.openxmlformats.org/officeDocument/2006/relationships" xmlns:p="http://schemas.openxmlformats.org/presentationml/2006/main" show="0">
   <p:cSld>
     <p:spTree>
       <p:nvGrpSpPr>
@@ -6425,7 +6384,14 @@
         <p:cNvGrpSpPr/>
         <p:nvPr/>
       </p:nvGrpSpPr>
-      <p:grpSpPr/>
+      <p:grpSpPr>
+        <a:xfrm>
+          <a:off x="0" y="0"/>
+          <a:ext cx="0" cy="0"/>
+          <a:chOff x="0" y="0"/>
+          <a:chExt cx="0" cy="0"/>
+        </a:xfrm>
+      </p:grpSpPr>
       <p:sp>
         <p:nvSpPr>
           <p:cNvPr id="2" name="TextBox 1"/>
@@ -6565,7 +6531,7 @@
 </file>
 
 <file path=ppt/slides/slide2.xml><?xml version="1.0" encoding="utf-8"?>
-<p:sld xmlns:a="http://schemas.openxmlformats.org/drawingml/2006/main" xmlns:p="http://schemas.openxmlformats.org/presentationml/2006/main" xmlns:r="http://schemas.openxmlformats.org/officeDocument/2006/relationships">
+<p:sld xmlns:a="http://schemas.openxmlformats.org/drawingml/2006/main" xmlns:r="http://schemas.openxmlformats.org/officeDocument/2006/relationships" xmlns:p="http://schemas.openxmlformats.org/presentationml/2006/main">
   <p:cSld>
     <p:spTree>
       <p:nvGrpSpPr>
@@ -6573,7 +6539,14 @@
         <p:cNvGrpSpPr/>
         <p:nvPr/>
       </p:nvGrpSpPr>
-      <p:grpSpPr/>
+      <p:grpSpPr>
+        <a:xfrm>
+          <a:off x="0" y="0"/>
+          <a:ext cx="0" cy="0"/>
+          <a:chOff x="0" y="0"/>
+          <a:chExt cx="0" cy="0"/>
+        </a:xfrm>
+      </p:grpSpPr>
       <p:sp>
         <p:nvSpPr>
           <p:cNvPr id="2" name="TextBox 1"/>
@@ -6729,7 +6702,7 @@
 </file>
 
 <file path=ppt/slides/slide20.xml><?xml version="1.0" encoding="utf-8"?>
-<p:sld xmlns:a="http://schemas.openxmlformats.org/drawingml/2006/main" xmlns:p="http://schemas.openxmlformats.org/presentationml/2006/main" xmlns:r="http://schemas.openxmlformats.org/officeDocument/2006/relationships" show="0">
+<p:sld xmlns:a="http://schemas.openxmlformats.org/drawingml/2006/main" xmlns:r="http://schemas.openxmlformats.org/officeDocument/2006/relationships" xmlns:p="http://schemas.openxmlformats.org/presentationml/2006/main" show="0">
   <p:cSld>
     <p:spTree>
       <p:nvGrpSpPr>
@@ -6737,7 +6710,14 @@
         <p:cNvGrpSpPr/>
         <p:nvPr/>
       </p:nvGrpSpPr>
-      <p:grpSpPr/>
+      <p:grpSpPr>
+        <a:xfrm>
+          <a:off x="0" y="0"/>
+          <a:ext cx="0" cy="0"/>
+          <a:chOff x="0" y="0"/>
+          <a:chExt cx="0" cy="0"/>
+        </a:xfrm>
+      </p:grpSpPr>
       <p:sp>
         <p:nvSpPr>
           <p:cNvPr id="2" name="TextBox 1"/>
@@ -6877,7 +6857,7 @@
 </file>
 
 <file path=ppt/slides/slide3.xml><?xml version="1.0" encoding="utf-8"?>
-<p:sld xmlns:a="http://schemas.openxmlformats.org/drawingml/2006/main" xmlns:p="http://schemas.openxmlformats.org/presentationml/2006/main" xmlns:r="http://schemas.openxmlformats.org/officeDocument/2006/relationships">
+<p:sld xmlns:a="http://schemas.openxmlformats.org/drawingml/2006/main" xmlns:r="http://schemas.openxmlformats.org/officeDocument/2006/relationships" xmlns:p="http://schemas.openxmlformats.org/presentationml/2006/main">
   <p:cSld>
     <p:spTree>
       <p:nvGrpSpPr>
@@ -6885,7 +6865,14 @@
         <p:cNvGrpSpPr/>
         <p:nvPr/>
       </p:nvGrpSpPr>
-      <p:grpSpPr/>
+      <p:grpSpPr>
+        <a:xfrm>
+          <a:off x="0" y="0"/>
+          <a:ext cx="0" cy="0"/>
+          <a:chOff x="0" y="0"/>
+          <a:chExt cx="0" cy="0"/>
+        </a:xfrm>
+      </p:grpSpPr>
       <p:sp>
         <p:nvSpPr>
           <p:cNvPr id="2" name="TextBox 1"/>
@@ -6895,7 +6882,7 @@
         <p:spPr>
           <a:xfrm>
             <a:off x="500000" y="300000"/>
-            <a:ext cx="9200000" cy="1150000"/>
+            <a:ext cx="9200000" cy="984885"/>
           </a:xfrm>
           <a:prstGeom prst="rect">
             <a:avLst/>
@@ -6910,14 +6897,137 @@
           <a:p>
             <a:pPr algn="l"/>
             <a:r>
-              <a:rPr sz="2900" b="1">
+              <a:rPr sz="2900" b="1" dirty="0">
                 <a:solidFill>
                   <a:srgbClr val="0B3D66"/>
                 </a:solidFill>
                 <a:latin typeface="Calibri"/>
               </a:rPr>
-              <a:t>Une plateforme reconstruite sur un contexte réel — et mon rôle</a:t>
-            </a:r>
+              <a:t>Une </a:t>
+            </a:r>
+            <a:r>
+              <a:rPr sz="2900" b="1" dirty="0" err="1">
+                <a:solidFill>
+                  <a:srgbClr val="0B3D66"/>
+                </a:solidFill>
+                <a:latin typeface="Calibri"/>
+              </a:rPr>
+              <a:t>plateforme</a:t>
+            </a:r>
+            <a:r>
+              <a:rPr sz="2900" b="1" dirty="0">
+                <a:solidFill>
+                  <a:srgbClr val="0B3D66"/>
+                </a:solidFill>
+                <a:latin typeface="Calibri"/>
+              </a:rPr>
+              <a:t> </a:t>
+            </a:r>
+            <a:r>
+              <a:rPr sz="2900" b="1" dirty="0" err="1">
+                <a:solidFill>
+                  <a:srgbClr val="0B3D66"/>
+                </a:solidFill>
+                <a:latin typeface="Calibri"/>
+              </a:rPr>
+              <a:t>reconstruite</a:t>
+            </a:r>
+            <a:r>
+              <a:rPr sz="2900" b="1" dirty="0">
+                <a:solidFill>
+                  <a:srgbClr val="0B3D66"/>
+                </a:solidFill>
+                <a:latin typeface="Calibri"/>
+              </a:rPr>
+              <a:t> sur un </a:t>
+            </a:r>
+            <a:r>
+              <a:rPr sz="2900" b="1" dirty="0" err="1">
+                <a:solidFill>
+                  <a:srgbClr val="0B3D66"/>
+                </a:solidFill>
+                <a:latin typeface="Calibri"/>
+              </a:rPr>
+              <a:t>contexte</a:t>
+            </a:r>
+            <a:r>
+              <a:rPr sz="2900" b="1" dirty="0">
+                <a:solidFill>
+                  <a:srgbClr val="0B3D66"/>
+                </a:solidFill>
+                <a:latin typeface="Calibri"/>
+              </a:rPr>
+              <a:t> </a:t>
+            </a:r>
+            <a:r>
+              <a:rPr sz="2900" b="1" dirty="0" err="1">
+                <a:solidFill>
+                  <a:srgbClr val="0B3D66"/>
+                </a:solidFill>
+                <a:latin typeface="Calibri"/>
+              </a:rPr>
+              <a:t>réel</a:t>
+            </a:r>
+            <a:r>
+              <a:rPr lang="fr-FR" sz="2900" b="1" dirty="0">
+                <a:solidFill>
+                  <a:srgbClr val="0B3D66"/>
+                </a:solidFill>
+                <a:latin typeface="Calibri"/>
+              </a:rPr>
+              <a:t>,</a:t>
+            </a:r>
+            <a:r>
+              <a:rPr sz="2900" b="1" dirty="0">
+                <a:solidFill>
+                  <a:srgbClr val="0B3D66"/>
+                </a:solidFill>
+                <a:latin typeface="Calibri"/>
+              </a:rPr>
+              <a:t> </a:t>
+            </a:r>
+            <a:r>
+              <a:rPr sz="2900" b="1" dirty="0" err="1">
+                <a:solidFill>
+                  <a:srgbClr val="0B3D66"/>
+                </a:solidFill>
+                <a:latin typeface="Calibri"/>
+              </a:rPr>
+              <a:t>mon</a:t>
+            </a:r>
+            <a:r>
+              <a:rPr sz="2900" b="1" dirty="0">
+                <a:solidFill>
+                  <a:srgbClr val="0B3D66"/>
+                </a:solidFill>
+                <a:latin typeface="Calibri"/>
+              </a:rPr>
+              <a:t> </a:t>
+            </a:r>
+            <a:r>
+              <a:rPr sz="2900" b="1" dirty="0" err="1">
+                <a:solidFill>
+                  <a:srgbClr val="0B3D66"/>
+                </a:solidFill>
+                <a:latin typeface="Calibri"/>
+              </a:rPr>
+              <a:t>rôle</a:t>
+            </a:r>
+            <a:r>
+              <a:rPr lang="fr-FR" sz="2900" b="1" dirty="0">
+                <a:solidFill>
+                  <a:srgbClr val="0B3D66"/>
+                </a:solidFill>
+                <a:latin typeface="Calibri"/>
+              </a:rPr>
+              <a:t> dans le projet</a:t>
+            </a:r>
+            <a:endParaRPr sz="2900" b="1" dirty="0">
+              <a:solidFill>
+                <a:srgbClr val="0B3D66"/>
+              </a:solidFill>
+              <a:latin typeface="Calibri"/>
+            </a:endParaRPr>
           </a:p>
         </p:txBody>
       </p:sp>
@@ -6969,8 +7079,8 @@
         </p:nvSpPr>
         <p:spPr>
           <a:xfrm>
-            <a:off x="600000" y="1650000"/>
-            <a:ext cx="11000000" cy="4600000"/>
+            <a:off x="600000" y="1656292"/>
+            <a:ext cx="11000000" cy="1769715"/>
           </a:xfrm>
           <a:prstGeom prst="rect">
             <a:avLst/>
@@ -6989,13 +7099,103 @@
               </a:spcAft>
             </a:pPr>
             <a:r>
-              <a:rPr sz="2100">
-                <a:solidFill>
-                  <a:srgbClr val="404040"/>
-                </a:solidFill>
-                <a:latin typeface="Calibri"/>
-              </a:rPr>
-              <a:t>•  Contexte métier réel vécu en alternance (Prévifrance)</a:t>
+              <a:rPr sz="2100" dirty="0">
+                <a:solidFill>
+                  <a:srgbClr val="404040"/>
+                </a:solidFill>
+                <a:latin typeface="Calibri"/>
+              </a:rPr>
+              <a:t>•  </a:t>
+            </a:r>
+            <a:r>
+              <a:rPr sz="2100" dirty="0" err="1">
+                <a:solidFill>
+                  <a:srgbClr val="404040"/>
+                </a:solidFill>
+                <a:latin typeface="Calibri"/>
+              </a:rPr>
+              <a:t>Contexte</a:t>
+            </a:r>
+            <a:r>
+              <a:rPr sz="2100" dirty="0">
+                <a:solidFill>
+                  <a:srgbClr val="404040"/>
+                </a:solidFill>
+                <a:latin typeface="Calibri"/>
+              </a:rPr>
+              <a:t> métier </a:t>
+            </a:r>
+            <a:r>
+              <a:rPr sz="2100" dirty="0" err="1">
+                <a:solidFill>
+                  <a:srgbClr val="404040"/>
+                </a:solidFill>
+                <a:latin typeface="Calibri"/>
+              </a:rPr>
+              <a:t>réel</a:t>
+            </a:r>
+            <a:r>
+              <a:rPr sz="2100" dirty="0">
+                <a:solidFill>
+                  <a:srgbClr val="404040"/>
+                </a:solidFill>
+                <a:latin typeface="Calibri"/>
+              </a:rPr>
+              <a:t> </a:t>
+            </a:r>
+            <a:r>
+              <a:rPr sz="2100" dirty="0" err="1">
+                <a:solidFill>
+                  <a:srgbClr val="404040"/>
+                </a:solidFill>
+                <a:latin typeface="Calibri"/>
+              </a:rPr>
+              <a:t>vécu</a:t>
+            </a:r>
+            <a:r>
+              <a:rPr sz="2100" dirty="0">
+                <a:solidFill>
+                  <a:srgbClr val="404040"/>
+                </a:solidFill>
+                <a:latin typeface="Calibri"/>
+              </a:rPr>
+              <a:t> </a:t>
+            </a:r>
+            <a:r>
+              <a:rPr sz="2100" dirty="0" err="1">
+                <a:solidFill>
+                  <a:srgbClr val="404040"/>
+                </a:solidFill>
+                <a:latin typeface="Calibri"/>
+              </a:rPr>
+              <a:t>en</a:t>
+            </a:r>
+            <a:r>
+              <a:rPr sz="2100" dirty="0">
+                <a:solidFill>
+                  <a:srgbClr val="404040"/>
+                </a:solidFill>
+                <a:latin typeface="Calibri"/>
+              </a:rPr>
+              <a:t> alternance (</a:t>
+            </a:r>
+            <a:r>
+              <a:rPr sz="2100" dirty="0" err="1">
+                <a:solidFill>
+                  <a:srgbClr val="404040"/>
+                </a:solidFill>
+                <a:latin typeface="Calibri"/>
+              </a:rPr>
+              <a:t>Prévifrance</a:t>
+            </a:r>
+            <a:r>
+              <a:rPr sz="2100" dirty="0">
+                <a:solidFill>
+                  <a:srgbClr val="404040"/>
+                </a:solidFill>
+                <a:latin typeface="Calibri"/>
+              </a:rPr>
+              <a:t>)</a:t>
             </a:r>
           </a:p>
           <a:p>
@@ -7005,13 +7205,85 @@
               </a:spcAft>
             </a:pPr>
             <a:r>
-              <a:rPr sz="2100">
-                <a:solidFill>
-                  <a:srgbClr val="404040"/>
-                </a:solidFill>
-                <a:latin typeface="Calibri"/>
-              </a:rPr>
-              <a:t>•  Plateforme entièrement RECONSTRUITE pour ce dossier</a:t>
+              <a:rPr sz="2100" dirty="0">
+                <a:solidFill>
+                  <a:srgbClr val="404040"/>
+                </a:solidFill>
+                <a:latin typeface="Calibri"/>
+              </a:rPr>
+              <a:t>•  </a:t>
+            </a:r>
+            <a:r>
+              <a:rPr sz="2100" dirty="0" err="1">
+                <a:solidFill>
+                  <a:srgbClr val="404040"/>
+                </a:solidFill>
+                <a:latin typeface="Calibri"/>
+              </a:rPr>
+              <a:t>Plateforme</a:t>
+            </a:r>
+            <a:r>
+              <a:rPr sz="2100" dirty="0">
+                <a:solidFill>
+                  <a:srgbClr val="404040"/>
+                </a:solidFill>
+                <a:latin typeface="Calibri"/>
+              </a:rPr>
+              <a:t> </a:t>
+            </a:r>
+            <a:r>
+              <a:rPr sz="2100" dirty="0" err="1">
+                <a:solidFill>
+                  <a:srgbClr val="404040"/>
+                </a:solidFill>
+                <a:latin typeface="Calibri"/>
+              </a:rPr>
+              <a:t>entièrement</a:t>
+            </a:r>
+            <a:r>
+              <a:rPr sz="2100" dirty="0">
+                <a:solidFill>
+                  <a:srgbClr val="404040"/>
+                </a:solidFill>
+                <a:latin typeface="Calibri"/>
+              </a:rPr>
+              <a:t> </a:t>
+            </a:r>
+            <a:r>
+              <a:rPr lang="fr-FR" sz="2100" dirty="0">
+                <a:solidFill>
+                  <a:srgbClr val="404040"/>
+                </a:solidFill>
+                <a:latin typeface="Calibri"/>
+              </a:rPr>
+              <a:t>reconstruire</a:t>
+            </a:r>
+            <a:r>
+              <a:rPr sz="2100" dirty="0">
+                <a:solidFill>
+                  <a:srgbClr val="404040"/>
+                </a:solidFill>
+                <a:latin typeface="Calibri"/>
+              </a:rPr>
+              <a:t> pour </a:t>
+            </a:r>
+            <a:r>
+              <a:rPr sz="2100" dirty="0" err="1">
+                <a:solidFill>
+                  <a:srgbClr val="404040"/>
+                </a:solidFill>
+                <a:latin typeface="Calibri"/>
+              </a:rPr>
+              <a:t>ce</a:t>
+            </a:r>
+            <a:r>
+              <a:rPr sz="2100" dirty="0">
+                <a:solidFill>
+                  <a:srgbClr val="404040"/>
+                </a:solidFill>
+                <a:latin typeface="Calibri"/>
+              </a:rPr>
+              <a:t> dossier</a:t>
             </a:r>
           </a:p>
           <a:p>
@@ -7021,13 +7293,103 @@
               </a:spcAft>
             </a:pPr>
             <a:r>
-              <a:rPr sz="2100">
-                <a:solidFill>
-                  <a:srgbClr val="404040"/>
-                </a:solidFill>
-                <a:latin typeface="Calibri"/>
-              </a:rPr>
-              <a:t>•  Fichier INSEE réel · référentiel adhérents synthétique (Faker)</a:t>
+              <a:rPr sz="2100" dirty="0">
+                <a:solidFill>
+                  <a:srgbClr val="404040"/>
+                </a:solidFill>
+                <a:latin typeface="Calibri"/>
+              </a:rPr>
+              <a:t>•  </a:t>
+            </a:r>
+            <a:r>
+              <a:rPr sz="2100" dirty="0" err="1">
+                <a:solidFill>
+                  <a:srgbClr val="404040"/>
+                </a:solidFill>
+                <a:latin typeface="Calibri"/>
+              </a:rPr>
+              <a:t>Fichier</a:t>
+            </a:r>
+            <a:r>
+              <a:rPr sz="2100" dirty="0">
+                <a:solidFill>
+                  <a:srgbClr val="404040"/>
+                </a:solidFill>
+                <a:latin typeface="Calibri"/>
+              </a:rPr>
+              <a:t> INSEE </a:t>
+            </a:r>
+            <a:r>
+              <a:rPr sz="2100" dirty="0" err="1">
+                <a:solidFill>
+                  <a:srgbClr val="404040"/>
+                </a:solidFill>
+                <a:latin typeface="Calibri"/>
+              </a:rPr>
+              <a:t>réel</a:t>
+            </a:r>
+            <a:r>
+              <a:rPr sz="2100" dirty="0">
+                <a:solidFill>
+                  <a:srgbClr val="404040"/>
+                </a:solidFill>
+                <a:latin typeface="Calibri"/>
+              </a:rPr>
+              <a:t> · </a:t>
+            </a:r>
+            <a:r>
+              <a:rPr sz="2100" dirty="0" err="1">
+                <a:solidFill>
+                  <a:srgbClr val="404040"/>
+                </a:solidFill>
+                <a:latin typeface="Calibri"/>
+              </a:rPr>
+              <a:t>référentiel</a:t>
+            </a:r>
+            <a:r>
+              <a:rPr sz="2100" dirty="0">
+                <a:solidFill>
+                  <a:srgbClr val="404040"/>
+                </a:solidFill>
+                <a:latin typeface="Calibri"/>
+              </a:rPr>
+              <a:t> </a:t>
+            </a:r>
+            <a:r>
+              <a:rPr sz="2100" dirty="0" err="1">
+                <a:solidFill>
+                  <a:srgbClr val="404040"/>
+                </a:solidFill>
+                <a:latin typeface="Calibri"/>
+              </a:rPr>
+              <a:t>adhérents</a:t>
+            </a:r>
+            <a:r>
+              <a:rPr sz="2100" dirty="0">
+                <a:solidFill>
+                  <a:srgbClr val="404040"/>
+                </a:solidFill>
+                <a:latin typeface="Calibri"/>
+              </a:rPr>
+              <a:t> </a:t>
+            </a:r>
+            <a:r>
+              <a:rPr sz="2100" dirty="0" err="1">
+                <a:solidFill>
+                  <a:srgbClr val="404040"/>
+                </a:solidFill>
+                <a:latin typeface="Calibri"/>
+              </a:rPr>
+              <a:t>synthétique</a:t>
+            </a:r>
+            <a:r>
+              <a:rPr sz="2100" dirty="0">
+                <a:solidFill>
+                  <a:srgbClr val="404040"/>
+                </a:solidFill>
+                <a:latin typeface="Calibri"/>
+              </a:rPr>
+              <a:t> (Faker)</a:t>
             </a:r>
           </a:p>
           <a:p>
@@ -7037,14 +7399,101 @@
               </a:spcAft>
             </a:pPr>
             <a:r>
-              <a:rPr sz="2100">
-                <a:solidFill>
-                  <a:srgbClr val="404040"/>
-                </a:solidFill>
-                <a:latin typeface="Calibri"/>
-              </a:rPr>
-              <a:t>•  J'ai vécu en production l'ingestion Eckert et l'incident</a:t>
-            </a:r>
+              <a:rPr sz="2100" dirty="0">
+                <a:solidFill>
+                  <a:srgbClr val="404040"/>
+                </a:solidFill>
+                <a:latin typeface="Calibri"/>
+              </a:rPr>
+              <a:t>•  </a:t>
+            </a:r>
+            <a:r>
+              <a:rPr sz="2100" dirty="0" err="1">
+                <a:solidFill>
+                  <a:srgbClr val="404040"/>
+                </a:solidFill>
+                <a:latin typeface="Calibri"/>
+              </a:rPr>
+              <a:t>J'ai</a:t>
+            </a:r>
+            <a:r>
+              <a:rPr sz="2100" dirty="0">
+                <a:solidFill>
+                  <a:srgbClr val="404040"/>
+                </a:solidFill>
+                <a:latin typeface="Calibri"/>
+              </a:rPr>
+              <a:t> </a:t>
+            </a:r>
+            <a:r>
+              <a:rPr sz="2100" dirty="0" err="1">
+                <a:solidFill>
+                  <a:srgbClr val="404040"/>
+                </a:solidFill>
+                <a:latin typeface="Calibri"/>
+              </a:rPr>
+              <a:t>vécu</a:t>
+            </a:r>
+            <a:r>
+              <a:rPr sz="2100" dirty="0">
+                <a:solidFill>
+                  <a:srgbClr val="404040"/>
+                </a:solidFill>
+                <a:latin typeface="Calibri"/>
+              </a:rPr>
+              <a:t> </a:t>
+            </a:r>
+            <a:r>
+              <a:rPr sz="2100" dirty="0" err="1">
+                <a:solidFill>
+                  <a:srgbClr val="404040"/>
+                </a:solidFill>
+                <a:latin typeface="Calibri"/>
+              </a:rPr>
+              <a:t>en</a:t>
+            </a:r>
+            <a:r>
+              <a:rPr sz="2100" dirty="0">
+                <a:solidFill>
+                  <a:srgbClr val="404040"/>
+                </a:solidFill>
+                <a:latin typeface="Calibri"/>
+              </a:rPr>
+              <a:t> production </a:t>
+            </a:r>
+            <a:r>
+              <a:rPr sz="2100" dirty="0" err="1">
+                <a:solidFill>
+                  <a:srgbClr val="404040"/>
+                </a:solidFill>
+                <a:latin typeface="Calibri"/>
+              </a:rPr>
+              <a:t>l'ingestion</a:t>
+            </a:r>
+            <a:r>
+              <a:rPr sz="2100" dirty="0">
+                <a:solidFill>
+                  <a:srgbClr val="404040"/>
+                </a:solidFill>
+                <a:latin typeface="Calibri"/>
+              </a:rPr>
+              <a:t> Eckert et </a:t>
+            </a:r>
+            <a:r>
+              <a:rPr sz="2100" dirty="0" err="1">
+                <a:solidFill>
+                  <a:srgbClr val="404040"/>
+                </a:solidFill>
+                <a:latin typeface="Calibri"/>
+              </a:rPr>
+              <a:t>l'incident</a:t>
+            </a:r>
+            <a:endParaRPr sz="2100" dirty="0">
+              <a:solidFill>
+                <a:srgbClr val="404040"/>
+              </a:solidFill>
+              <a:latin typeface="Calibri"/>
+            </a:endParaRPr>
           </a:p>
         </p:txBody>
       </p:sp>
@@ -7057,7 +7506,7 @@
 </file>
 
 <file path=ppt/slides/slide4.xml><?xml version="1.0" encoding="utf-8"?>
-<p:sld xmlns:a="http://schemas.openxmlformats.org/drawingml/2006/main" xmlns:p="http://schemas.openxmlformats.org/presentationml/2006/main" xmlns:r="http://schemas.openxmlformats.org/officeDocument/2006/relationships">
+<p:sld xmlns:a="http://schemas.openxmlformats.org/drawingml/2006/main" xmlns:r="http://schemas.openxmlformats.org/officeDocument/2006/relationships" xmlns:p="http://schemas.openxmlformats.org/presentationml/2006/main">
   <p:cSld>
     <p:spTree>
       <p:nvGrpSpPr>
@@ -7065,7 +7514,14 @@
         <p:cNvGrpSpPr/>
         <p:nvPr/>
       </p:nvGrpSpPr>
-      <p:grpSpPr/>
+      <p:grpSpPr>
+        <a:xfrm>
+          <a:off x="0" y="0"/>
+          <a:ext cx="0" cy="0"/>
+          <a:chOff x="0" y="0"/>
+          <a:chExt cx="0" cy="0"/>
+        </a:xfrm>
+      </p:grpSpPr>
       <p:sp>
         <p:nvSpPr>
           <p:cNvPr id="2" name="TextBox 1"/>
@@ -7237,7 +7693,7 @@
 </file>
 
 <file path=ppt/slides/slide5.xml><?xml version="1.0" encoding="utf-8"?>
-<p:sld xmlns:a="http://schemas.openxmlformats.org/drawingml/2006/main" xmlns:p="http://schemas.openxmlformats.org/presentationml/2006/main" xmlns:r="http://schemas.openxmlformats.org/officeDocument/2006/relationships">
+<p:sld xmlns:a="http://schemas.openxmlformats.org/drawingml/2006/main" xmlns:r="http://schemas.openxmlformats.org/officeDocument/2006/relationships" xmlns:p="http://schemas.openxmlformats.org/presentationml/2006/main">
   <p:cSld>
     <p:spTree>
       <p:nvGrpSpPr>
@@ -7245,7 +7701,14 @@
         <p:cNvGrpSpPr/>
         <p:nvPr/>
       </p:nvGrpSpPr>
-      <p:grpSpPr/>
+      <p:grpSpPr>
+        <a:xfrm>
+          <a:off x="0" y="0"/>
+          <a:ext cx="0" cy="0"/>
+          <a:chOff x="0" y="0"/>
+          <a:chExt cx="0" cy="0"/>
+        </a:xfrm>
+      </p:grpSpPr>
       <p:sp>
         <p:nvSpPr>
           <p:cNvPr id="2" name="TextBox 1"/>
@@ -7401,7 +7864,7 @@
 </file>
 
 <file path=ppt/slides/slide6.xml><?xml version="1.0" encoding="utf-8"?>
-<p:sld xmlns:a="http://schemas.openxmlformats.org/drawingml/2006/main" xmlns:p="http://schemas.openxmlformats.org/presentationml/2006/main" xmlns:r="http://schemas.openxmlformats.org/officeDocument/2006/relationships">
+<p:sld xmlns:a="http://schemas.openxmlformats.org/drawingml/2006/main" xmlns:r="http://schemas.openxmlformats.org/officeDocument/2006/relationships" xmlns:p="http://schemas.openxmlformats.org/presentationml/2006/main">
   <p:cSld>
     <p:spTree>
       <p:nvGrpSpPr>
@@ -7409,7 +7872,14 @@
         <p:cNvGrpSpPr/>
         <p:nvPr/>
       </p:nvGrpSpPr>
-      <p:grpSpPr/>
+      <p:grpSpPr>
+        <a:xfrm>
+          <a:off x="0" y="0"/>
+          <a:ext cx="0" cy="0"/>
+          <a:chOff x="0" y="0"/>
+          <a:chExt cx="0" cy="0"/>
+        </a:xfrm>
+      </p:grpSpPr>
       <p:sp>
         <p:nvSpPr>
           <p:cNvPr id="2" name="TextBox 1"/>
@@ -7581,7 +8051,7 @@
 </file>
 
 <file path=ppt/slides/slide7.xml><?xml version="1.0" encoding="utf-8"?>
-<p:sld xmlns:a="http://schemas.openxmlformats.org/drawingml/2006/main" xmlns:p="http://schemas.openxmlformats.org/presentationml/2006/main" xmlns:r="http://schemas.openxmlformats.org/officeDocument/2006/relationships">
+<p:sld xmlns:a="http://schemas.openxmlformats.org/drawingml/2006/main" xmlns:r="http://schemas.openxmlformats.org/officeDocument/2006/relationships" xmlns:p="http://schemas.openxmlformats.org/presentationml/2006/main">
   <p:cSld>
     <p:spTree>
       <p:nvGrpSpPr>
@@ -7589,7 +8059,14 @@
         <p:cNvGrpSpPr/>
         <p:nvPr/>
       </p:nvGrpSpPr>
-      <p:grpSpPr/>
+      <p:grpSpPr>
+        <a:xfrm>
+          <a:off x="0" y="0"/>
+          <a:ext cx="0" cy="0"/>
+          <a:chOff x="0" y="0"/>
+          <a:chExt cx="0" cy="0"/>
+        </a:xfrm>
+      </p:grpSpPr>
       <p:sp>
         <p:nvSpPr>
           <p:cNvPr id="2" name="TextBox 1"/>
@@ -7674,7 +8151,7 @@
         <p:spPr>
           <a:xfrm>
             <a:off x="600000" y="1650000"/>
-            <a:ext cx="11000000" cy="4600000"/>
+            <a:ext cx="11000000" cy="1769715"/>
           </a:xfrm>
           <a:prstGeom prst="rect">
             <a:avLst/>
@@ -7693,13 +8170,31 @@
               </a:spcAft>
             </a:pPr>
             <a:r>
-              <a:rPr sz="2100">
-                <a:solidFill>
-                  <a:srgbClr val="404040"/>
-                </a:solidFill>
-                <a:latin typeface="Calibri"/>
-              </a:rPr>
-              <a:t>•  bronze (brut) · silver (typé) · gold (métier) · ops (journal)</a:t>
+              <a:rPr sz="2100" dirty="0">
+                <a:solidFill>
+                  <a:srgbClr val="404040"/>
+                </a:solidFill>
+                <a:latin typeface="Calibri"/>
+              </a:rPr>
+              <a:t>•  bronze (brut) · silver (</a:t>
+            </a:r>
+            <a:r>
+              <a:rPr sz="2100" dirty="0" err="1">
+                <a:solidFill>
+                  <a:srgbClr val="404040"/>
+                </a:solidFill>
+                <a:latin typeface="Calibri"/>
+              </a:rPr>
+              <a:t>typé</a:t>
+            </a:r>
+            <a:r>
+              <a:rPr sz="2100" dirty="0">
+                <a:solidFill>
+                  <a:srgbClr val="404040"/>
+                </a:solidFill>
+                <a:latin typeface="Calibri"/>
+              </a:rPr>
+              <a:t>) · gold (métier) · ops (journal)</a:t>
             </a:r>
           </a:p>
           <a:p>
@@ -7709,14 +8204,65 @@
               </a:spcAft>
             </a:pPr>
             <a:r>
-              <a:rPr sz="2100">
-                <a:solidFill>
-                  <a:srgbClr val="404040"/>
-                </a:solidFill>
-                <a:latin typeface="Calibri"/>
-              </a:rPr>
-              <a:t>•  Deux rôles : le pipeline écrit, le métier lit gold seulement</a:t>
-            </a:r>
+              <a:rPr sz="2100" dirty="0">
+                <a:solidFill>
+                  <a:srgbClr val="404040"/>
+                </a:solidFill>
+                <a:latin typeface="Calibri"/>
+              </a:rPr>
+              <a:t>•  Deux </a:t>
+            </a:r>
+            <a:r>
+              <a:rPr sz="2100" dirty="0" err="1">
+                <a:solidFill>
+                  <a:srgbClr val="404040"/>
+                </a:solidFill>
+                <a:latin typeface="Calibri"/>
+              </a:rPr>
+              <a:t>rôles</a:t>
+            </a:r>
+            <a:r>
+              <a:rPr sz="2100" dirty="0">
+                <a:solidFill>
+                  <a:srgbClr val="404040"/>
+                </a:solidFill>
+                <a:latin typeface="Calibri"/>
+              </a:rPr>
+              <a:t> : le pipeline </a:t>
+            </a:r>
+            <a:r>
+              <a:rPr sz="2100" dirty="0" err="1">
+                <a:solidFill>
+                  <a:srgbClr val="404040"/>
+                </a:solidFill>
+                <a:latin typeface="Calibri"/>
+              </a:rPr>
+              <a:t>écrit</a:t>
+            </a:r>
+            <a:r>
+              <a:rPr sz="2100" dirty="0">
+                <a:solidFill>
+                  <a:srgbClr val="404040"/>
+                </a:solidFill>
+                <a:latin typeface="Calibri"/>
+              </a:rPr>
+              <a:t>, le métier lit gold </a:t>
+            </a:r>
+            <a:r>
+              <a:rPr sz="2100" dirty="0" err="1">
+                <a:solidFill>
+                  <a:srgbClr val="404040"/>
+                </a:solidFill>
+                <a:latin typeface="Calibri"/>
+              </a:rPr>
+              <a:t>seulement</a:t>
+            </a:r>
+            <a:endParaRPr sz="2100" dirty="0">
+              <a:solidFill>
+                <a:srgbClr val="404040"/>
+              </a:solidFill>
+              <a:latin typeface="Calibri"/>
+            </a:endParaRPr>
           </a:p>
           <a:p>
             <a:pPr>
@@ -7725,13 +8271,121 @@
               </a:spcAft>
             </a:pPr>
             <a:r>
-              <a:rPr sz="2100">
-                <a:solidFill>
-                  <a:srgbClr val="404040"/>
-                </a:solidFill>
-                <a:latin typeface="Calibri"/>
-              </a:rPr>
-              <a:t>•  Le rôle lecture ne peut ni écrire ni lire le brut — TESTÉ</a:t>
+              <a:rPr sz="2100" dirty="0">
+                <a:solidFill>
+                  <a:srgbClr val="404040"/>
+                </a:solidFill>
+                <a:latin typeface="Calibri"/>
+              </a:rPr>
+              <a:t>•  Le </a:t>
+            </a:r>
+            <a:r>
+              <a:rPr sz="2100" dirty="0" err="1">
+                <a:solidFill>
+                  <a:srgbClr val="404040"/>
+                </a:solidFill>
+                <a:latin typeface="Calibri"/>
+              </a:rPr>
+              <a:t>rôle</a:t>
+            </a:r>
+            <a:r>
+              <a:rPr sz="2100" dirty="0">
+                <a:solidFill>
+                  <a:srgbClr val="404040"/>
+                </a:solidFill>
+                <a:latin typeface="Calibri"/>
+              </a:rPr>
+              <a:t> lecture ne </a:t>
+            </a:r>
+            <a:r>
+              <a:rPr sz="2100" dirty="0" err="1">
+                <a:solidFill>
+                  <a:srgbClr val="404040"/>
+                </a:solidFill>
+                <a:latin typeface="Calibri"/>
+              </a:rPr>
+              <a:t>peut</a:t>
+            </a:r>
+            <a:r>
+              <a:rPr sz="2100" dirty="0">
+                <a:solidFill>
+                  <a:srgbClr val="404040"/>
+                </a:solidFill>
+                <a:latin typeface="Calibri"/>
+              </a:rPr>
+              <a:t> </a:t>
+            </a:r>
+            <a:r>
+              <a:rPr sz="2100" dirty="0" err="1">
+                <a:solidFill>
+                  <a:srgbClr val="404040"/>
+                </a:solidFill>
+                <a:latin typeface="Calibri"/>
+              </a:rPr>
+              <a:t>ni</a:t>
+            </a:r>
+            <a:r>
+              <a:rPr sz="2100" dirty="0">
+                <a:solidFill>
+                  <a:srgbClr val="404040"/>
+                </a:solidFill>
+                <a:latin typeface="Calibri"/>
+              </a:rPr>
+              <a:t> </a:t>
+            </a:r>
+            <a:r>
+              <a:rPr sz="2100" dirty="0" err="1">
+                <a:solidFill>
+                  <a:srgbClr val="404040"/>
+                </a:solidFill>
+                <a:latin typeface="Calibri"/>
+              </a:rPr>
+              <a:t>écrire</a:t>
+            </a:r>
+            <a:r>
+              <a:rPr sz="2100" dirty="0">
+                <a:solidFill>
+                  <a:srgbClr val="404040"/>
+                </a:solidFill>
+                <a:latin typeface="Calibri"/>
+              </a:rPr>
+              <a:t> </a:t>
+            </a:r>
+            <a:r>
+              <a:rPr sz="2100" dirty="0" err="1">
+                <a:solidFill>
+                  <a:srgbClr val="404040"/>
+                </a:solidFill>
+                <a:latin typeface="Calibri"/>
+              </a:rPr>
+              <a:t>ni</a:t>
+            </a:r>
+            <a:r>
+              <a:rPr sz="2100" dirty="0">
+                <a:solidFill>
+                  <a:srgbClr val="404040"/>
+                </a:solidFill>
+                <a:latin typeface="Calibri"/>
+              </a:rPr>
+              <a:t> lire le brut</a:t>
+            </a:r>
+            <a:r>
+              <a:rPr lang="fr-FR" sz="2100" dirty="0">
+                <a:solidFill>
+                  <a:srgbClr val="404040"/>
+                </a:solidFill>
+                <a:latin typeface="Calibri"/>
+              </a:rPr>
+              <a:t> -&gt;</a:t>
+            </a:r>
+            <a:r>
+              <a:rPr sz="2100" dirty="0">
+                <a:solidFill>
+                  <a:srgbClr val="404040"/>
+                </a:solidFill>
+                <a:latin typeface="Calibri"/>
+              </a:rPr>
+              <a:t> TESTÉ</a:t>
             </a:r>
           </a:p>
           <a:p>
@@ -7741,14 +8395,83 @@
               </a:spcAft>
             </a:pPr>
             <a:r>
-              <a:rPr sz="2100">
-                <a:solidFill>
-                  <a:srgbClr val="404040"/>
-                </a:solidFill>
-                <a:latin typeface="Calibri"/>
-              </a:rPr>
-              <a:t>•  Le métier consomme une vue déjà priorisée</a:t>
-            </a:r>
+              <a:rPr sz="2100" dirty="0">
+                <a:solidFill>
+                  <a:srgbClr val="404040"/>
+                </a:solidFill>
+                <a:latin typeface="Calibri"/>
+              </a:rPr>
+              <a:t>•  Le métier </a:t>
+            </a:r>
+            <a:r>
+              <a:rPr sz="2100" dirty="0" err="1">
+                <a:solidFill>
+                  <a:srgbClr val="404040"/>
+                </a:solidFill>
+                <a:latin typeface="Calibri"/>
+              </a:rPr>
+              <a:t>consomme</a:t>
+            </a:r>
+            <a:r>
+              <a:rPr sz="2100" dirty="0">
+                <a:solidFill>
+                  <a:srgbClr val="404040"/>
+                </a:solidFill>
+                <a:latin typeface="Calibri"/>
+              </a:rPr>
+              <a:t> </a:t>
+            </a:r>
+            <a:r>
+              <a:rPr sz="2100" dirty="0" err="1">
+                <a:solidFill>
+                  <a:srgbClr val="404040"/>
+                </a:solidFill>
+                <a:latin typeface="Calibri"/>
+              </a:rPr>
+              <a:t>une</a:t>
+            </a:r>
+            <a:r>
+              <a:rPr sz="2100" dirty="0">
+                <a:solidFill>
+                  <a:srgbClr val="404040"/>
+                </a:solidFill>
+                <a:latin typeface="Calibri"/>
+              </a:rPr>
+              <a:t> </a:t>
+            </a:r>
+            <a:r>
+              <a:rPr sz="2100" dirty="0" err="1">
+                <a:solidFill>
+                  <a:srgbClr val="404040"/>
+                </a:solidFill>
+                <a:latin typeface="Calibri"/>
+              </a:rPr>
+              <a:t>vue</a:t>
+            </a:r>
+            <a:r>
+              <a:rPr sz="2100" dirty="0">
+                <a:solidFill>
+                  <a:srgbClr val="404040"/>
+                </a:solidFill>
+                <a:latin typeface="Calibri"/>
+              </a:rPr>
+              <a:t> déjà </a:t>
+            </a:r>
+            <a:r>
+              <a:rPr sz="2100" dirty="0" err="1">
+                <a:solidFill>
+                  <a:srgbClr val="404040"/>
+                </a:solidFill>
+                <a:latin typeface="Calibri"/>
+              </a:rPr>
+              <a:t>priorisée</a:t>
+            </a:r>
+            <a:endParaRPr sz="2100" dirty="0">
+              <a:solidFill>
+                <a:srgbClr val="404040"/>
+              </a:solidFill>
+              <a:latin typeface="Calibri"/>
+            </a:endParaRPr>
           </a:p>
         </p:txBody>
       </p:sp>
@@ -7761,7 +8484,7 @@
 </file>
 
 <file path=ppt/slides/slide8.xml><?xml version="1.0" encoding="utf-8"?>
-<p:sld xmlns:a="http://schemas.openxmlformats.org/drawingml/2006/main" xmlns:p="http://schemas.openxmlformats.org/presentationml/2006/main" xmlns:r="http://schemas.openxmlformats.org/officeDocument/2006/relationships">
+<p:sld xmlns:a="http://schemas.openxmlformats.org/drawingml/2006/main" xmlns:r="http://schemas.openxmlformats.org/officeDocument/2006/relationships" xmlns:p="http://schemas.openxmlformats.org/presentationml/2006/main">
   <p:cSld>
     <p:spTree>
       <p:nvGrpSpPr>
@@ -7769,7 +8492,14 @@
         <p:cNvGrpSpPr/>
         <p:nvPr/>
       </p:nvGrpSpPr>
-      <p:grpSpPr/>
+      <p:grpSpPr>
+        <a:xfrm>
+          <a:off x="0" y="0"/>
+          <a:ext cx="0" cy="0"/>
+          <a:chOff x="0" y="0"/>
+          <a:chExt cx="0" cy="0"/>
+        </a:xfrm>
+      </p:grpSpPr>
       <p:sp>
         <p:nvSpPr>
           <p:cNvPr id="2" name="TextBox 1"/>
@@ -7941,7 +8671,7 @@
 </file>
 
 <file path=ppt/slides/slide9.xml><?xml version="1.0" encoding="utf-8"?>
-<p:sld xmlns:a="http://schemas.openxmlformats.org/drawingml/2006/main" xmlns:p="http://schemas.openxmlformats.org/presentationml/2006/main" xmlns:r="http://schemas.openxmlformats.org/officeDocument/2006/relationships">
+<p:sld xmlns:a="http://schemas.openxmlformats.org/drawingml/2006/main" xmlns:r="http://schemas.openxmlformats.org/officeDocument/2006/relationships" xmlns:p="http://schemas.openxmlformats.org/presentationml/2006/main">
   <p:cSld>
     <p:spTree>
       <p:nvGrpSpPr>
@@ -7949,7 +8679,14 @@
         <p:cNvGrpSpPr/>
         <p:nvPr/>
       </p:nvGrpSpPr>
-      <p:grpSpPr/>
+      <p:grpSpPr>
+        <a:xfrm>
+          <a:off x="0" y="0"/>
+          <a:ext cx="0" cy="0"/>
+          <a:chOff x="0" y="0"/>
+          <a:chExt cx="0" cy="0"/>
+        </a:xfrm>
+      </p:grpSpPr>
       <p:sp>
         <p:nvSpPr>
           <p:cNvPr id="2" name="TextBox 1"/>
@@ -8073,7 +8810,7 @@
           <p:nvPr/>
         </p:nvPicPr>
         <p:blipFill>
-          <a:blip r:embed="rId2"/>
+          <a:blip r:embed="rId3"/>
           <a:stretch>
             <a:fillRect/>
           </a:stretch>
@@ -8417,7 +9154,7 @@
 </file>
 
 <file path=ppt/theme/theme2.xml><?xml version="1.0" encoding="utf-8"?>
-<a:theme xmlns:a="http://schemas.openxmlformats.org/drawingml/2006/main" name="Office Theme">
+<a:theme xmlns:a="http://schemas.openxmlformats.org/drawingml/2006/main" name="Thème Office">
   <a:themeElements>
     <a:clrScheme name="Office">
       <a:dk1>
@@ -8427,44 +9164,44 @@
         <a:sysClr val="window" lastClr="FFFFFF"/>
       </a:lt1>
       <a:dk2>
-        <a:srgbClr val="1F497D"/>
+        <a:srgbClr val="0E2841"/>
       </a:dk2>
       <a:lt2>
-        <a:srgbClr val="EEECE1"/>
+        <a:srgbClr val="E8E8E8"/>
       </a:lt2>
       <a:accent1>
-        <a:srgbClr val="4F81BD"/>
+        <a:srgbClr val="156082"/>
       </a:accent1>
       <a:accent2>
-        <a:srgbClr val="C0504D"/>
+        <a:srgbClr val="E97132"/>
       </a:accent2>
       <a:accent3>
-        <a:srgbClr val="9BBB59"/>
+        <a:srgbClr val="196B24"/>
       </a:accent3>
       <a:accent4>
-        <a:srgbClr val="8064A2"/>
+        <a:srgbClr val="0F9ED5"/>
       </a:accent4>
       <a:accent5>
-        <a:srgbClr val="4BACC6"/>
+        <a:srgbClr val="A02B93"/>
       </a:accent5>
       <a:accent6>
-        <a:srgbClr val="F79646"/>
+        <a:srgbClr val="4EA72E"/>
       </a:accent6>
       <a:hlink>
-        <a:srgbClr val="0000FF"/>
+        <a:srgbClr val="467886"/>
       </a:hlink>
       <a:folHlink>
-        <a:srgbClr val="800080"/>
+        <a:srgbClr val="96607D"/>
       </a:folHlink>
     </a:clrScheme>
     <a:fontScheme name="Office">
       <a:majorFont>
-        <a:latin typeface="Calibri"/>
+        <a:latin typeface="Aptos Display" panose="02110004020202020204"/>
         <a:ea typeface=""/>
         <a:cs typeface=""/>
-        <a:font script="Jpan" typeface="ＭＳ Ｐゴシック"/>
+        <a:font script="Jpan" typeface="游ゴシック Light"/>
         <a:font script="Hang" typeface="맑은 고딕"/>
-        <a:font script="Hans" typeface="宋体"/>
+        <a:font script="Hans" typeface="等线 Light"/>
         <a:font script="Hant" typeface="新細明體"/>
         <a:font script="Arab" typeface="Times New Roman"/>
         <a:font script="Hebr" typeface="Times New Roman"/>
@@ -8492,14 +9229,31 @@
         <a:font script="Viet" typeface="Times New Roman"/>
         <a:font script="Uigh" typeface="Microsoft Uighur"/>
         <a:font script="Geor" typeface="Sylfaen"/>
+        <a:font script="Armn" typeface="Arial"/>
+        <a:font script="Bugi" typeface="Leelawadee UI"/>
+        <a:font script="Bopo" typeface="Microsoft JhengHei"/>
+        <a:font script="Java" typeface="Javanese Text"/>
+        <a:font script="Lisu" typeface="Segoe UI"/>
+        <a:font script="Mymr" typeface="Myanmar Text"/>
+        <a:font script="Nkoo" typeface="Ebrima"/>
+        <a:font script="Olck" typeface="Nirmala UI"/>
+        <a:font script="Osma" typeface="Ebrima"/>
+        <a:font script="Phag" typeface="Phagspa"/>
+        <a:font script="Syrn" typeface="Estrangelo Edessa"/>
+        <a:font script="Syrj" typeface="Estrangelo Edessa"/>
+        <a:font script="Syre" typeface="Estrangelo Edessa"/>
+        <a:font script="Sora" typeface="Nirmala UI"/>
+        <a:font script="Tale" typeface="Microsoft Tai Le"/>
+        <a:font script="Talu" typeface="Microsoft New Tai Lue"/>
+        <a:font script="Tfng" typeface="Ebrima"/>
       </a:majorFont>
       <a:minorFont>
-        <a:latin typeface="Calibri"/>
+        <a:latin typeface="Aptos" panose="02110004020202020204"/>
         <a:ea typeface=""/>
         <a:cs typeface=""/>
-        <a:font script="Jpan" typeface="ＭＳ Ｐゴシック"/>
+        <a:font script="Jpan" typeface="游ゴシック"/>
         <a:font script="Hang" typeface="맑은 고딕"/>
-        <a:font script="Hans" typeface="宋体"/>
+        <a:font script="Hans" typeface="等线"/>
         <a:font script="Hant" typeface="新細明體"/>
         <a:font script="Arab" typeface="Arial"/>
         <a:font script="Hebr" typeface="Arial"/>
@@ -8527,6 +9281,23 @@
         <a:font script="Viet" typeface="Arial"/>
         <a:font script="Uigh" typeface="Microsoft Uighur"/>
         <a:font script="Geor" typeface="Sylfaen"/>
+        <a:font script="Armn" typeface="Arial"/>
+        <a:font script="Bugi" typeface="Leelawadee UI"/>
+        <a:font script="Bopo" typeface="Microsoft JhengHei"/>
+        <a:font script="Java" typeface="Javanese Text"/>
+        <a:font script="Lisu" typeface="Segoe UI"/>
+        <a:font script="Mymr" typeface="Myanmar Text"/>
+        <a:font script="Nkoo" typeface="Ebrima"/>
+        <a:font script="Olck" typeface="Nirmala UI"/>
+        <a:font script="Osma" typeface="Ebrima"/>
+        <a:font script="Phag" typeface="Phagspa"/>
+        <a:font script="Syrn" typeface="Estrangelo Edessa"/>
+        <a:font script="Syrj" typeface="Estrangelo Edessa"/>
+        <a:font script="Syre" typeface="Estrangelo Edessa"/>
+        <a:font script="Sora" typeface="Nirmala UI"/>
+        <a:font script="Tale" typeface="Microsoft Tai Le"/>
+        <a:font script="Talu" typeface="Microsoft New Tai Lue"/>
+        <a:font script="Tfng" typeface="Ebrima"/>
       </a:minorFont>
     </a:fontScheme>
     <a:fmtScheme name="Office">
@@ -8538,180 +9309,136 @@
           <a:gsLst>
             <a:gs pos="0">
               <a:schemeClr val="phClr">
-                <a:tint val="50000"/>
-                <a:satMod val="300000"/>
+                <a:lumMod val="110000"/>
+                <a:satMod val="105000"/>
+                <a:tint val="67000"/>
               </a:schemeClr>
             </a:gs>
-            <a:gs pos="35000">
+            <a:gs pos="50000">
               <a:schemeClr val="phClr">
-                <a:tint val="37000"/>
-                <a:satMod val="300000"/>
+                <a:lumMod val="105000"/>
+                <a:satMod val="103000"/>
+                <a:tint val="73000"/>
               </a:schemeClr>
             </a:gs>
             <a:gs pos="100000">
               <a:schemeClr val="phClr">
-                <a:tint val="15000"/>
-                <a:satMod val="350000"/>
+                <a:lumMod val="105000"/>
+                <a:satMod val="109000"/>
+                <a:tint val="81000"/>
               </a:schemeClr>
             </a:gs>
           </a:gsLst>
-          <a:lin ang="16200000" scaled="1"/>
+          <a:lin ang="5400000" scaled="0"/>
         </a:gradFill>
         <a:gradFill rotWithShape="1">
           <a:gsLst>
             <a:gs pos="0">
               <a:schemeClr val="phClr">
-                <a:tint val="100000"/>
+                <a:satMod val="103000"/>
+                <a:lumMod val="102000"/>
+                <a:tint val="94000"/>
+              </a:schemeClr>
+            </a:gs>
+            <a:gs pos="50000">
+              <a:schemeClr val="phClr">
+                <a:satMod val="110000"/>
+                <a:lumMod val="100000"/>
                 <a:shade val="100000"/>
-                <a:satMod val="130000"/>
               </a:schemeClr>
             </a:gs>
             <a:gs pos="100000">
               <a:schemeClr val="phClr">
-                <a:tint val="50000"/>
-                <a:shade val="100000"/>
-                <a:satMod val="350000"/>
+                <a:lumMod val="99000"/>
+                <a:satMod val="120000"/>
+                <a:shade val="78000"/>
               </a:schemeClr>
             </a:gs>
           </a:gsLst>
-          <a:lin ang="16200000" scaled="0"/>
+          <a:lin ang="5400000" scaled="0"/>
         </a:gradFill>
       </a:fillStyleLst>
       <a:lnStyleLst>
-        <a:ln w="9525" cap="flat" cmpd="sng" algn="ctr">
+        <a:ln w="12700" cap="flat" cmpd="sng" algn="ctr">
           <a:solidFill>
-            <a:schemeClr val="phClr">
-              <a:shade val="95000"/>
-              <a:satMod val="105000"/>
-            </a:schemeClr>
+            <a:schemeClr val="phClr"/>
           </a:solidFill>
           <a:prstDash val="solid"/>
+          <a:miter lim="800000"/>
+        </a:ln>
+        <a:ln w="19050" cap="flat" cmpd="sng" algn="ctr">
+          <a:solidFill>
+            <a:schemeClr val="phClr"/>
+          </a:solidFill>
+          <a:prstDash val="solid"/>
+          <a:miter lim="800000"/>
         </a:ln>
         <a:ln w="25400" cap="flat" cmpd="sng" algn="ctr">
           <a:solidFill>
             <a:schemeClr val="phClr"/>
           </a:solidFill>
           <a:prstDash val="solid"/>
-        </a:ln>
-        <a:ln w="38100" cap="flat" cmpd="sng" algn="ctr">
-          <a:solidFill>
-            <a:schemeClr val="phClr"/>
-          </a:solidFill>
-          <a:prstDash val="solid"/>
+          <a:miter lim="800000"/>
         </a:ln>
       </a:lnStyleLst>
       <a:effectStyleLst>
         <a:effectStyle>
+          <a:effectLst/>
+        </a:effectStyle>
+        <a:effectStyle>
+          <a:effectLst/>
+        </a:effectStyle>
+        <a:effectStyle>
           <a:effectLst>
-            <a:outerShdw blurRad="40000" dist="20000" dir="5400000" rotWithShape="0">
+            <a:outerShdw blurRad="57150" dist="19050" dir="5400000" algn="ctr" rotWithShape="0">
               <a:srgbClr val="000000">
-                <a:alpha val="38000"/>
+                <a:alpha val="63000"/>
               </a:srgbClr>
             </a:outerShdw>
           </a:effectLst>
-        </a:effectStyle>
-        <a:effectStyle>
-          <a:effectLst>
-            <a:outerShdw blurRad="40000" dist="23000" dir="5400000" rotWithShape="0">
-              <a:srgbClr val="000000">
-                <a:alpha val="35000"/>
-              </a:srgbClr>
-            </a:outerShdw>
-          </a:effectLst>
-        </a:effectStyle>
-        <a:effectStyle>
-          <a:effectLst>
-            <a:outerShdw blurRad="40000" dist="23000" dir="5400000" rotWithShape="0">
-              <a:srgbClr val="000000">
-                <a:alpha val="35000"/>
-              </a:srgbClr>
-            </a:outerShdw>
-          </a:effectLst>
-          <a:scene3d>
-            <a:camera prst="orthographicFront">
-              <a:rot lat="0" lon="0" rev="0"/>
-            </a:camera>
-            <a:lightRig rig="threePt" dir="t">
-              <a:rot lat="0" lon="0" rev="1200000"/>
-            </a:lightRig>
-          </a:scene3d>
-          <a:sp3d>
-            <a:bevelT w="63500" h="25400"/>
-          </a:sp3d>
         </a:effectStyle>
       </a:effectStyleLst>
       <a:bgFillStyleLst>
         <a:solidFill>
           <a:schemeClr val="phClr"/>
         </a:solidFill>
+        <a:solidFill>
+          <a:schemeClr val="phClr">
+            <a:tint val="95000"/>
+            <a:satMod val="170000"/>
+          </a:schemeClr>
+        </a:solidFill>
         <a:gradFill rotWithShape="1">
           <a:gsLst>
             <a:gs pos="0">
               <a:schemeClr val="phClr">
-                <a:tint val="40000"/>
-                <a:satMod val="350000"/>
+                <a:tint val="93000"/>
+                <a:satMod val="150000"/>
+                <a:shade val="98000"/>
+                <a:lumMod val="102000"/>
               </a:schemeClr>
             </a:gs>
-            <a:gs pos="40000">
+            <a:gs pos="50000">
               <a:schemeClr val="phClr">
-                <a:tint val="45000"/>
-                <a:shade val="99000"/>
-                <a:satMod val="350000"/>
+                <a:tint val="98000"/>
+                <a:satMod val="130000"/>
+                <a:shade val="90000"/>
+                <a:lumMod val="103000"/>
               </a:schemeClr>
             </a:gs>
             <a:gs pos="100000">
               <a:schemeClr val="phClr">
-                <a:shade val="20000"/>
-                <a:satMod val="255000"/>
+                <a:shade val="63000"/>
+                <a:satMod val="120000"/>
               </a:schemeClr>
             </a:gs>
           </a:gsLst>
-          <a:path path="circle">
-            <a:fillToRect l="50000" t="-80000" r="50000" b="180000"/>
-          </a:path>
-        </a:gradFill>
-        <a:gradFill rotWithShape="1">
-          <a:gsLst>
-            <a:gs pos="0">
-              <a:schemeClr val="phClr">
-                <a:tint val="80000"/>
-                <a:satMod val="300000"/>
-              </a:schemeClr>
-            </a:gs>
-            <a:gs pos="100000">
-              <a:schemeClr val="phClr">
-                <a:shade val="30000"/>
-                <a:satMod val="200000"/>
-              </a:schemeClr>
-            </a:gs>
-          </a:gsLst>
-          <a:path path="circle">
-            <a:fillToRect l="50000" t="50000" r="50000" b="50000"/>
-          </a:path>
+          <a:lin ang="5400000" scaled="0"/>
         </a:gradFill>
       </a:bgFillStyleLst>
     </a:fmtScheme>
   </a:themeElements>
   <a:objectDefaults>
-    <a:spDef>
-      <a:spPr/>
-      <a:bodyPr/>
-      <a:lstStyle/>
-      <a:style>
-        <a:lnRef idx="1">
-          <a:schemeClr val="accent1"/>
-        </a:lnRef>
-        <a:fillRef idx="3">
-          <a:schemeClr val="accent1"/>
-        </a:fillRef>
-        <a:effectRef idx="2">
-          <a:schemeClr val="accent1"/>
-        </a:effectRef>
-        <a:fontRef idx="minor">
-          <a:schemeClr val="lt1"/>
-        </a:fontRef>
-      </a:style>
-    </a:spDef>
     <a:lnDef>
       <a:spPr/>
       <a:bodyPr/>
@@ -8733,5 +9460,10 @@
     </a:lnDef>
   </a:objectDefaults>
   <a:extraClrSchemeLst/>
+  <a:extLst>
+    <a:ext uri="{05A4C25C-085E-4340-85A3-A5531E510DB2}">
+      <thm15:themeFamily xmlns:thm15="http://schemas.microsoft.com/office/thememl/2012/main" name="Office Theme" id="{2E142A2C-CD16-42D6-873A-C26D2A0506FA}" vid="{1BDDFF52-6CD6-40A5-AB3C-68EB2F1E4D0A}"/>
+    </a:ext>
+  </a:extLst>
 </a:theme>
 </file>
</xml_diff>

<commit_message>
pptx : puces diapos 6-10 mises à jour + suppression des notes
Patch en place (tools/patch_pptx.py), préserve la mise en forme :
- puces alignées sur les retours (coûts détaillés, 3 rôles/DBA, ELT,
  tâches du DAG, partage Postgres/Spark, INSEE partiel)
- notes de commentaire retirées (le 'à dire' est dans conducteur_soutenance.md)

Co-Authored-By: Claude Opus 4.8 <noreply@anthropic.com>
</commit_message>
<xml_diff>
--- a/soutenance/support_eckert.pptx
+++ b/soutenance/support_eckert.pptx
@@ -721,13 +721,7 @@
         <p:txBody>
           <a:bodyPr/>
           <a:lstStyle/>
-          <a:p>
-            <a:r>
-              <a:rPr lang="fr-FR" dirty="0"/>
-              <a:t>=</a:t>
-            </a:r>
-            <a:endParaRPr dirty="0"/>
-          </a:p>
+          <a:p/>
         </p:txBody>
       </p:sp>
       <p:sp>
@@ -4976,7 +4970,7 @@
           <a:p>
             <a:pPr>
               <a:spcAft>
-                <a:spcPts val="1000"/>
+                <a:spcPts val="800"/>
               </a:spcAft>
             </a:pPr>
             <a:r>
@@ -4986,7 +4980,23 @@
                 </a:solidFill>
                 <a:latin typeface="Calibri"/>
               </a:rPr>
-              <a:t>•  Rapprochement sur cluster · 3 niveaux CERTAIN / PROBABLE / A_VERIFIER · app FINISHED</a:t>
+              <a:t>•  Postgres stocke ; Spark lit/écrit via JDBC · INSEE partiel reconstruit</a:t>
+            </a:r>
+          </a:p>
+          <a:p>
+            <a:pPr>
+              <a:spcAft>
+                <a:spcPts val="800"/>
+              </a:spcAft>
+            </a:pPr>
+            <a:r>
+              <a:rPr sz="1700">
+                <a:solidFill>
+                  <a:srgbClr val="404040"/>
+                </a:solidFill>
+                <a:latin typeface="Calibri"/>
+              </a:rPr>
+              <a:t>•  3 niveaux · 4 162 contrats · 88 M€ certain · Spark justifié par le cumul</a:t>
             </a:r>
           </a:p>
         </p:txBody>
@@ -7979,7 +7989,7 @@
           <a:p>
             <a:pPr>
               <a:spcAft>
-                <a:spcPts val="1000"/>
+                <a:spcPts val="800"/>
               </a:spcAft>
             </a:pPr>
             <a:r>
@@ -7989,13 +7999,13 @@
                 </a:solidFill>
                 <a:latin typeface="Calibri"/>
               </a:rPr>
-              <a:t>•  Local (retenu) : ~ coût du temps humain seul</a:t>
+              <a:t>•  Local : logiciel gratuit, mais ~45 €/mois de temps humain (+ ~1 350 € de build)</a:t>
             </a:r>
           </a:p>
           <a:p>
             <a:pPr>
               <a:spcAft>
-                <a:spcPts val="1000"/>
+                <a:spcPts val="800"/>
               </a:spcAft>
             </a:pPr>
             <a:r>
@@ -8005,13 +8015,13 @@
                 </a:solidFill>
                 <a:latin typeface="Calibri"/>
               </a:rPr>
-              <a:t>•  Cloud Azure : ~ 50 à 145 € / mois</a:t>
+              <a:t>•  Cloud Azure (ressources détaillées) : ~30 – 90 €/mois</a:t>
             </a:r>
           </a:p>
           <a:p>
             <a:pPr>
               <a:spcAft>
-                <a:spcPts val="1000"/>
+                <a:spcPts val="800"/>
               </a:spcAft>
             </a:pPr>
             <a:r>
@@ -8021,13 +8031,13 @@
                 </a:solidFill>
                 <a:latin typeface="Calibri"/>
               </a:rPr>
-              <a:t>•  SaaS Snowflake/Fabric : ~ 80 à 250 € / mois</a:t>
+              <a:t>•  SaaS : Snowflake ~40-80 € (usage) · Fabric ~180-305 € (capacité)</a:t>
             </a:r>
           </a:p>
           <a:p>
             <a:pPr>
               <a:spcAft>
-                <a:spcPts val="1000"/>
+                <a:spcPts val="800"/>
               </a:spcAft>
             </a:pPr>
             <a:r>
@@ -8037,7 +8047,7 @@
                 </a:solidFill>
                 <a:latin typeface="Calibri"/>
               </a:rPr>
-              <a:t>•  SaaS écarté (réel) : coût récurrent + souveraineté des données</a:t>
+              <a:t>•  SaaS écarté (réel) : coût récurrent + souveraineté des données de santé</a:t>
             </a:r>
           </a:p>
         </p:txBody>
@@ -8166,312 +8176,66 @@
           <a:p>
             <a:pPr>
               <a:spcAft>
-                <a:spcPts val="1000"/>
+                <a:spcPts val="800"/>
               </a:spcAft>
             </a:pPr>
             <a:r>
-              <a:rPr sz="2100" dirty="0">
+              <a:rPr sz="2100">
                 <a:solidFill>
                   <a:srgbClr val="404040"/>
                 </a:solidFill>
                 <a:latin typeface="Calibri"/>
               </a:rPr>
-              <a:t>•  bronze (brut) · silver (</a:t>
-            </a:r>
-            <a:r>
-              <a:rPr sz="2100" dirty="0" err="1">
-                <a:solidFill>
-                  <a:srgbClr val="404040"/>
-                </a:solidFill>
-                <a:latin typeface="Calibri"/>
-              </a:rPr>
-              <a:t>typé</a:t>
-            </a:r>
-            <a:r>
-              <a:rPr sz="2100" dirty="0">
-                <a:solidFill>
-                  <a:srgbClr val="404040"/>
-                </a:solidFill>
-                <a:latin typeface="Calibri"/>
-              </a:rPr>
-              <a:t>) · gold (métier) · ops (journal)</a:t>
+              <a:t>•  bronze (brut) · silver (typé) · gold (métier) · ops (journal)</a:t>
             </a:r>
           </a:p>
           <a:p>
             <a:pPr>
               <a:spcAft>
-                <a:spcPts val="1000"/>
+                <a:spcPts val="800"/>
               </a:spcAft>
             </a:pPr>
             <a:r>
-              <a:rPr sz="2100" dirty="0">
+              <a:rPr sz="2100">
                 <a:solidFill>
                   <a:srgbClr val="404040"/>
                 </a:solidFill>
                 <a:latin typeface="Calibri"/>
               </a:rPr>
-              <a:t>•  Deux </a:t>
-            </a:r>
-            <a:r>
-              <a:rPr sz="2100" dirty="0" err="1">
-                <a:solidFill>
-                  <a:srgbClr val="404040"/>
-                </a:solidFill>
-                <a:latin typeface="Calibri"/>
-              </a:rPr>
-              <a:t>rôles</a:t>
-            </a:r>
-            <a:r>
-              <a:rPr sz="2100" dirty="0">
-                <a:solidFill>
-                  <a:srgbClr val="404040"/>
-                </a:solidFill>
-                <a:latin typeface="Calibri"/>
-              </a:rPr>
-              <a:t> : le pipeline </a:t>
-            </a:r>
-            <a:r>
-              <a:rPr sz="2100" dirty="0" err="1">
-                <a:solidFill>
-                  <a:srgbClr val="404040"/>
-                </a:solidFill>
-                <a:latin typeface="Calibri"/>
-              </a:rPr>
-              <a:t>écrit</a:t>
-            </a:r>
-            <a:r>
-              <a:rPr sz="2100" dirty="0">
-                <a:solidFill>
-                  <a:srgbClr val="404040"/>
-                </a:solidFill>
-                <a:latin typeface="Calibri"/>
-              </a:rPr>
-              <a:t>, le métier lit gold </a:t>
-            </a:r>
-            <a:r>
-              <a:rPr sz="2100" dirty="0" err="1">
-                <a:solidFill>
-                  <a:srgbClr val="404040"/>
-                </a:solidFill>
-                <a:latin typeface="Calibri"/>
-              </a:rPr>
-              <a:t>seulement</a:t>
-            </a:r>
-            <a:endParaRPr sz="2100" dirty="0">
-              <a:solidFill>
-                <a:srgbClr val="404040"/>
-              </a:solidFill>
-              <a:latin typeface="Calibri"/>
-            </a:endParaRPr>
+              <a:t>•  Trois rôles : administration (DBA), écriture (pipeline), lecture (métier)</a:t>
+            </a:r>
           </a:p>
           <a:p>
             <a:pPr>
               <a:spcAft>
-                <a:spcPts val="1000"/>
+                <a:spcPts val="800"/>
               </a:spcAft>
             </a:pPr>
             <a:r>
-              <a:rPr sz="2100" dirty="0">
+              <a:rPr sz="2100">
                 <a:solidFill>
                   <a:srgbClr val="404040"/>
                 </a:solidFill>
                 <a:latin typeface="Calibri"/>
               </a:rPr>
-              <a:t>•  Le </a:t>
-            </a:r>
-            <a:r>
-              <a:rPr sz="2100" dirty="0" err="1">
-                <a:solidFill>
-                  <a:srgbClr val="404040"/>
-                </a:solidFill>
-                <a:latin typeface="Calibri"/>
-              </a:rPr>
-              <a:t>rôle</a:t>
-            </a:r>
-            <a:r>
-              <a:rPr sz="2100" dirty="0">
-                <a:solidFill>
-                  <a:srgbClr val="404040"/>
-                </a:solidFill>
-                <a:latin typeface="Calibri"/>
-              </a:rPr>
-              <a:t> lecture ne </a:t>
-            </a:r>
-            <a:r>
-              <a:rPr sz="2100" dirty="0" err="1">
-                <a:solidFill>
-                  <a:srgbClr val="404040"/>
-                </a:solidFill>
-                <a:latin typeface="Calibri"/>
-              </a:rPr>
-              <a:t>peut</a:t>
-            </a:r>
-            <a:r>
-              <a:rPr sz="2100" dirty="0">
-                <a:solidFill>
-                  <a:srgbClr val="404040"/>
-                </a:solidFill>
-                <a:latin typeface="Calibri"/>
-              </a:rPr>
-              <a:t> </a:t>
-            </a:r>
-            <a:r>
-              <a:rPr sz="2100" dirty="0" err="1">
-                <a:solidFill>
-                  <a:srgbClr val="404040"/>
-                </a:solidFill>
-                <a:latin typeface="Calibri"/>
-              </a:rPr>
-              <a:t>ni</a:t>
-            </a:r>
-            <a:r>
-              <a:rPr sz="2100" dirty="0">
-                <a:solidFill>
-                  <a:srgbClr val="404040"/>
-                </a:solidFill>
-                <a:latin typeface="Calibri"/>
-              </a:rPr>
-              <a:t> </a:t>
-            </a:r>
-            <a:r>
-              <a:rPr sz="2100" dirty="0" err="1">
-                <a:solidFill>
-                  <a:srgbClr val="404040"/>
-                </a:solidFill>
-                <a:latin typeface="Calibri"/>
-              </a:rPr>
-              <a:t>écrire</a:t>
-            </a:r>
-            <a:r>
-              <a:rPr sz="2100" dirty="0">
-                <a:solidFill>
-                  <a:srgbClr val="404040"/>
-                </a:solidFill>
-                <a:latin typeface="Calibri"/>
-              </a:rPr>
-              <a:t> </a:t>
-            </a:r>
-            <a:r>
-              <a:rPr sz="2100" dirty="0" err="1">
-                <a:solidFill>
-                  <a:srgbClr val="404040"/>
-                </a:solidFill>
-                <a:latin typeface="Calibri"/>
-              </a:rPr>
-              <a:t>ni</a:t>
-            </a:r>
-            <a:r>
-              <a:rPr sz="2100" dirty="0">
-                <a:solidFill>
-                  <a:srgbClr val="404040"/>
-                </a:solidFill>
-                <a:latin typeface="Calibri"/>
-              </a:rPr>
-              <a:t> lire le brut</a:t>
-            </a:r>
-            <a:r>
-              <a:rPr lang="fr-FR" sz="2100" dirty="0">
-                <a:solidFill>
-                  <a:srgbClr val="404040"/>
-                </a:solidFill>
-                <a:latin typeface="Calibri"/>
-              </a:rPr>
-              <a:t> -&gt;</a:t>
-            </a:r>
-            <a:r>
-              <a:rPr sz="2100" dirty="0">
-                <a:solidFill>
-                  <a:srgbClr val="404040"/>
-                </a:solidFill>
-                <a:latin typeface="Calibri"/>
-              </a:rPr>
-              <a:t> TESTÉ</a:t>
+              <a:t>•  La lecture ne peut ni écrire ni lire le brut — TESTÉ</a:t>
             </a:r>
           </a:p>
           <a:p>
             <a:pPr>
               <a:spcAft>
-                <a:spcPts val="1000"/>
+                <a:spcPts val="800"/>
               </a:spcAft>
             </a:pPr>
             <a:r>
-              <a:rPr sz="2100" dirty="0">
+              <a:rPr sz="2100">
                 <a:solidFill>
                   <a:srgbClr val="404040"/>
                 </a:solidFill>
                 <a:latin typeface="Calibri"/>
               </a:rPr>
-              <a:t>•  Le métier </a:t>
-            </a:r>
-            <a:r>
-              <a:rPr sz="2100" dirty="0" err="1">
-                <a:solidFill>
-                  <a:srgbClr val="404040"/>
-                </a:solidFill>
-                <a:latin typeface="Calibri"/>
-              </a:rPr>
-              <a:t>consomme</a:t>
-            </a:r>
-            <a:r>
-              <a:rPr sz="2100" dirty="0">
-                <a:solidFill>
-                  <a:srgbClr val="404040"/>
-                </a:solidFill>
-                <a:latin typeface="Calibri"/>
-              </a:rPr>
-              <a:t> </a:t>
-            </a:r>
-            <a:r>
-              <a:rPr sz="2100" dirty="0" err="1">
-                <a:solidFill>
-                  <a:srgbClr val="404040"/>
-                </a:solidFill>
-                <a:latin typeface="Calibri"/>
-              </a:rPr>
-              <a:t>une</a:t>
-            </a:r>
-            <a:r>
-              <a:rPr sz="2100" dirty="0">
-                <a:solidFill>
-                  <a:srgbClr val="404040"/>
-                </a:solidFill>
-                <a:latin typeface="Calibri"/>
-              </a:rPr>
-              <a:t> </a:t>
-            </a:r>
-            <a:r>
-              <a:rPr sz="2100" dirty="0" err="1">
-                <a:solidFill>
-                  <a:srgbClr val="404040"/>
-                </a:solidFill>
-                <a:latin typeface="Calibri"/>
-              </a:rPr>
-              <a:t>vue</a:t>
-            </a:r>
-            <a:r>
-              <a:rPr sz="2100" dirty="0">
-                <a:solidFill>
-                  <a:srgbClr val="404040"/>
-                </a:solidFill>
-                <a:latin typeface="Calibri"/>
-              </a:rPr>
-              <a:t> déjà </a:t>
-            </a:r>
-            <a:r>
-              <a:rPr sz="2100" dirty="0" err="1">
-                <a:solidFill>
-                  <a:srgbClr val="404040"/>
-                </a:solidFill>
-                <a:latin typeface="Calibri"/>
-              </a:rPr>
-              <a:t>priorisée</a:t>
-            </a:r>
-            <a:endParaRPr sz="2100" dirty="0">
-              <a:solidFill>
-                <a:srgbClr val="404040"/>
-              </a:solidFill>
-              <a:latin typeface="Calibri"/>
-            </a:endParaRPr>
+              <a:t>•  Le métier consomme une vue déjà priorisée</a:t>
+            </a:r>
           </a:p>
         </p:txBody>
       </p:sp>
@@ -8599,7 +8363,7 @@
           <a:p>
             <a:pPr>
               <a:spcAft>
-                <a:spcPts val="1000"/>
+                <a:spcPts val="800"/>
               </a:spcAft>
             </a:pPr>
             <a:r>
@@ -8609,13 +8373,13 @@
                 </a:solidFill>
                 <a:latin typeface="Calibri"/>
               </a:rPr>
-              <a:t>•  Fil de l'eau (SQL) : typage, nettoyage, déduplication dans le moteur</a:t>
+              <a:t>•  Choix ELT : charger le brut, puis transformer (rejouabilité + au plus près)</a:t>
             </a:r>
           </a:p>
           <a:p>
             <a:pPr>
               <a:spcAft>
-                <a:spcPts val="1000"/>
+                <a:spcPts val="800"/>
               </a:spcAft>
             </a:pPr>
             <a:r>
@@ -8625,13 +8389,13 @@
                 </a:solidFill>
                 <a:latin typeface="Calibri"/>
               </a:rPr>
-              <a:t>•  Orchestration (Airflow) : enchaîne et fiabilise</a:t>
+              <a:t>•  Fil de l'eau (SQL) : typage, nettoyage, déduplication</a:t>
             </a:r>
           </a:p>
           <a:p>
             <a:pPr>
               <a:spcAft>
-                <a:spcPts val="1000"/>
+                <a:spcPts val="800"/>
               </a:spcAft>
             </a:pPr>
             <a:r>
@@ -8641,13 +8405,13 @@
                 </a:solidFill>
                 <a:latin typeface="Calibri"/>
               </a:rPr>
-              <a:t>•  Distribué (Spark) : absorbe le volume du rapprochement</a:t>
+              <a:t>•  Orchestration (Airflow) : enchaîne et fiabilise</a:t>
             </a:r>
           </a:p>
           <a:p>
             <a:pPr>
               <a:spcAft>
-                <a:spcPts val="1000"/>
+                <a:spcPts val="800"/>
               </a:spcAft>
             </a:pPr>
             <a:r>
@@ -8657,7 +8421,7 @@
                 </a:solidFill>
                 <a:latin typeface="Calibri"/>
               </a:rPr>
-              <a:t>•  Chaque méthode produit une donnée demandée</a:t>
+              <a:t>•  Distribué (Spark) : absorbe le volume du rapprochement</a:t>
             </a:r>
           </a:p>
         </p:txBody>
@@ -8786,7 +8550,7 @@
           <a:p>
             <a:pPr>
               <a:spcAft>
-                <a:spcPts val="1000"/>
+                <a:spcPts val="800"/>
               </a:spcAft>
             </a:pPr>
             <a:r>
@@ -8796,7 +8560,23 @@
                 </a:solidFill>
                 <a:latin typeface="Calibri"/>
               </a:rPr>
-              <a:t>•  4 tâches · retries · SLA · callbacks d'alerte · exécution réelle data.gouv</a:t>
+              <a:t>•  4 tâches : catalogue data.gouv → validation contrat → bronze → silver</a:t>
+            </a:r>
+          </a:p>
+          <a:p>
+            <a:pPr>
+              <a:spcAft>
+                <a:spcPts val="800"/>
+              </a:spcAft>
+            </a:pPr>
+            <a:r>
+              <a:rPr sz="1700">
+                <a:solidFill>
+                  <a:srgbClr val="404040"/>
+                </a:solidFill>
+                <a:latin typeface="Calibri"/>
+              </a:rPr>
+              <a:t>•  Retries · SLA · callbacks d'alerte · exécution réelle sur le fichier INSEE</a:t>
             </a:r>
           </a:p>
         </p:txBody>

</xml_diff>

<commit_message>
MinIO câblé pour de vrai (bronze objet) + correctifs conducteur/diapo
- src/eckert/ingestion/stockage_objet.py : dépôt du fichier brut reçu dans
  MinIO + manifeste (boto3). Câblé dans le DAG réel (telecharger_et_valider)
  et le DAG démo (tâche archiver_minio). boto3 ajouté aux deps Airflow.
- Bronze à deux étages documenté (fichiers MinIO / lignes Postgres) —
  livrable C4-2-1 + preuve C4-2-1_minio_bronze.txt + inventaire.
- Conducteur : diapo 9 (rôle de MinIO dans le flux), diapo 17 (limite
  supervision -> solution concrète Prometheus/Grafana + exporteurs).
- pptx : puces ELT (MinIO) et bilan (supervision) mises à jour.

Co-Authored-By: Claude Opus 4.8 <noreply@anthropic.com>
</commit_message>
<xml_diff>
--- a/soutenance/support_eckert.pptx
+++ b/soutenance/support_eckert.pptx
@@ -6159,7 +6159,7 @@
           <a:p>
             <a:pPr>
               <a:spcAft>
-                <a:spcPts val="1000"/>
+                <a:spcPts val="800"/>
               </a:spcAft>
             </a:pPr>
             <a:r>
@@ -6169,13 +6169,13 @@
                 </a:solidFill>
                 <a:latin typeface="Calibri"/>
               </a:rPr>
-              <a:t>•  Chaîne complète prouvée : ingestion → Spark → gold → restitution</a:t>
+              <a:t>•  Chaîne complète prouvée : ingestion → MinIO → Spark → gold → restitution</a:t>
             </a:r>
           </a:p>
           <a:p>
             <a:pPr>
               <a:spcAft>
-                <a:spcPts val="1000"/>
+                <a:spcPts val="800"/>
               </a:spcAft>
             </a:pPr>
             <a:r>
@@ -6191,7 +6191,7 @@
           <a:p>
             <a:pPr>
               <a:spcAft>
-                <a:spcPts val="1000"/>
+                <a:spcPts val="800"/>
               </a:spcAft>
             </a:pPr>
             <a:r>
@@ -6201,13 +6201,13 @@
                 </a:solidFill>
                 <a:latin typeface="Calibri"/>
               </a:rPr>
-              <a:t>•  Limites : Postgres unique · Spark lancé manuellement · pas de supervision infra</a:t>
+              <a:t>•  Limites : Postgres unique · Spark lancé manuellement · supervision applicative</a:t>
             </a:r>
           </a:p>
           <a:p>
             <a:pPr>
               <a:spcAft>
-                <a:spcPts val="1000"/>
+                <a:spcPts val="800"/>
               </a:spcAft>
             </a:pPr>
             <a:r>
@@ -6217,7 +6217,7 @@
                 </a:solidFill>
                 <a:latin typeface="Calibri"/>
               </a:rPr>
-              <a:t>•  À poursuivre : déclenchement Spark par Airflow, supervision d'infra</a:t>
+              <a:t>•  À poursuivre : Spark via Airflow · supervision infra (Prometheus/Grafana + exporteurs)</a:t>
             </a:r>
           </a:p>
         </p:txBody>
@@ -8373,7 +8373,7 @@
                 </a:solidFill>
                 <a:latin typeface="Calibri"/>
               </a:rPr>
-              <a:t>•  Choix ELT : charger le brut, puis transformer (rejouabilité + au plus près)</a:t>
+              <a:t>•  Choix ELT : le brut d'abord (fichiers → MinIO objet, lignes → Postgres), transfo ensuite</a:t>
             </a:r>
           </a:p>
           <a:p>

</xml_diff>